<commit_message>
Update Funding Hub Antigravity Workshop presentation file
</commit_message>
<xml_diff>
--- a/Funding_Hub_Antigravity_Workshop.pptx
+++ b/Funding_Hub_Antigravity_Workshop.pptx
@@ -5,38 +5,39 @@
     <p:sldMasterId id="2147483648" r:id="rId1"/>
   </p:sldMasterIdLst>
   <p:notesMasterIdLst>
-    <p:notesMasterId r:id="rId31"/>
+    <p:notesMasterId r:id="rId32"/>
   </p:notesMasterIdLst>
   <p:sldIdLst>
     <p:sldId id="294" r:id="rId2"/>
-    <p:sldId id="257" r:id="rId3"/>
-    <p:sldId id="259" r:id="rId4"/>
-    <p:sldId id="260" r:id="rId5"/>
-    <p:sldId id="261" r:id="rId6"/>
-    <p:sldId id="262" r:id="rId7"/>
-    <p:sldId id="263" r:id="rId8"/>
-    <p:sldId id="264" r:id="rId9"/>
-    <p:sldId id="265" r:id="rId10"/>
-    <p:sldId id="266" r:id="rId11"/>
-    <p:sldId id="267" r:id="rId12"/>
-    <p:sldId id="268" r:id="rId13"/>
-    <p:sldId id="269" r:id="rId14"/>
-    <p:sldId id="271" r:id="rId15"/>
-    <p:sldId id="272" r:id="rId16"/>
-    <p:sldId id="273" r:id="rId17"/>
-    <p:sldId id="278" r:id="rId18"/>
-    <p:sldId id="279" r:id="rId19"/>
-    <p:sldId id="280" r:id="rId20"/>
-    <p:sldId id="297" r:id="rId21"/>
-    <p:sldId id="281" r:id="rId22"/>
-    <p:sldId id="296" r:id="rId23"/>
-    <p:sldId id="282" r:id="rId24"/>
-    <p:sldId id="298" r:id="rId25"/>
-    <p:sldId id="284" r:id="rId26"/>
-    <p:sldId id="285" r:id="rId27"/>
-    <p:sldId id="295" r:id="rId28"/>
-    <p:sldId id="292" r:id="rId29"/>
-    <p:sldId id="293" r:id="rId30"/>
+    <p:sldId id="299" r:id="rId3"/>
+    <p:sldId id="257" r:id="rId4"/>
+    <p:sldId id="259" r:id="rId5"/>
+    <p:sldId id="260" r:id="rId6"/>
+    <p:sldId id="261" r:id="rId7"/>
+    <p:sldId id="262" r:id="rId8"/>
+    <p:sldId id="263" r:id="rId9"/>
+    <p:sldId id="264" r:id="rId10"/>
+    <p:sldId id="265" r:id="rId11"/>
+    <p:sldId id="266" r:id="rId12"/>
+    <p:sldId id="267" r:id="rId13"/>
+    <p:sldId id="268" r:id="rId14"/>
+    <p:sldId id="269" r:id="rId15"/>
+    <p:sldId id="271" r:id="rId16"/>
+    <p:sldId id="272" r:id="rId17"/>
+    <p:sldId id="273" r:id="rId18"/>
+    <p:sldId id="278" r:id="rId19"/>
+    <p:sldId id="279" r:id="rId20"/>
+    <p:sldId id="280" r:id="rId21"/>
+    <p:sldId id="297" r:id="rId22"/>
+    <p:sldId id="281" r:id="rId23"/>
+    <p:sldId id="296" r:id="rId24"/>
+    <p:sldId id="282" r:id="rId25"/>
+    <p:sldId id="298" r:id="rId26"/>
+    <p:sldId id="284" r:id="rId27"/>
+    <p:sldId id="285" r:id="rId28"/>
+    <p:sldId id="295" r:id="rId29"/>
+    <p:sldId id="292" r:id="rId30"/>
+    <p:sldId id="293" r:id="rId31"/>
   </p:sldIdLst>
   <p:sldSz cx="12192000" cy="6858000"/>
   <p:notesSz cx="6858000" cy="12192000"/>
@@ -417,7 +418,7 @@
           <a:p>
             <a:fld id="{F7021451-1387-4CA6-816F-3879F97B5CBC}" type="slidenum">
               <a:rPr lang="en-US"/>
-              <a:t>10</a:t>
+              <a:t>11</a:t>
             </a:fld>
             <a:endParaRPr lang="en-US"/>
           </a:p>
@@ -501,7 +502,7 @@
           <a:p>
             <a:fld id="{F7021451-1387-4CA6-816F-3879F97B5CBC}" type="slidenum">
               <a:rPr lang="en-US"/>
-              <a:t>11</a:t>
+              <a:t>12</a:t>
             </a:fld>
             <a:endParaRPr lang="en-US"/>
           </a:p>
@@ -585,7 +586,7 @@
           <a:p>
             <a:fld id="{F7021451-1387-4CA6-816F-3879F97B5CBC}" type="slidenum">
               <a:rPr lang="en-US"/>
-              <a:t>12</a:t>
+              <a:t>13</a:t>
             </a:fld>
             <a:endParaRPr lang="en-US"/>
           </a:p>
@@ -669,7 +670,7 @@
           <a:p>
             <a:fld id="{F7021451-1387-4CA6-816F-3879F97B5CBC}" type="slidenum">
               <a:rPr lang="en-US"/>
-              <a:t>13</a:t>
+              <a:t>14</a:t>
             </a:fld>
             <a:endParaRPr lang="en-US"/>
           </a:p>
@@ -753,7 +754,7 @@
           <a:p>
             <a:fld id="{F7021451-1387-4CA6-816F-3879F97B5CBC}" type="slidenum">
               <a:rPr lang="en-US"/>
-              <a:t>14</a:t>
+              <a:t>15</a:t>
             </a:fld>
             <a:endParaRPr lang="en-US"/>
           </a:p>
@@ -837,7 +838,7 @@
           <a:p>
             <a:fld id="{F7021451-1387-4CA6-816F-3879F97B5CBC}" type="slidenum">
               <a:rPr lang="en-US"/>
-              <a:t>15</a:t>
+              <a:t>16</a:t>
             </a:fld>
             <a:endParaRPr lang="en-US"/>
           </a:p>
@@ -921,7 +922,7 @@
           <a:p>
             <a:fld id="{F7021451-1387-4CA6-816F-3879F97B5CBC}" type="slidenum">
               <a:rPr lang="en-US"/>
-              <a:t>16</a:t>
+              <a:t>17</a:t>
             </a:fld>
             <a:endParaRPr lang="en-US"/>
           </a:p>
@@ -1005,7 +1006,7 @@
           <a:p>
             <a:fld id="{F7021451-1387-4CA6-816F-3879F97B5CBC}" type="slidenum">
               <a:rPr lang="en-US"/>
-              <a:t>17</a:t>
+              <a:t>18</a:t>
             </a:fld>
             <a:endParaRPr lang="en-US"/>
           </a:p>
@@ -1089,7 +1090,7 @@
           <a:p>
             <a:fld id="{F7021451-1387-4CA6-816F-3879F97B5CBC}" type="slidenum">
               <a:rPr lang="en-US"/>
-              <a:t>18</a:t>
+              <a:t>19</a:t>
             </a:fld>
             <a:endParaRPr lang="en-US"/>
           </a:p>
@@ -1173,7 +1174,7 @@
           <a:p>
             <a:fld id="{F7021451-1387-4CA6-816F-3879F97B5CBC}" type="slidenum">
               <a:rPr lang="en-US"/>
-              <a:t>19</a:t>
+              <a:t>20</a:t>
             </a:fld>
             <a:endParaRPr lang="en-US"/>
           </a:p>
@@ -1257,7 +1258,7 @@
           <a:p>
             <a:fld id="{F7021451-1387-4CA6-816F-3879F97B5CBC}" type="slidenum">
               <a:rPr lang="en-US"/>
-              <a:t>2</a:t>
+              <a:t>3</a:t>
             </a:fld>
             <a:endParaRPr lang="en-US"/>
           </a:p>
@@ -1341,7 +1342,7 @@
           <a:p>
             <a:fld id="{F7021451-1387-4CA6-816F-3879F97B5CBC}" type="slidenum">
               <a:rPr lang="en-US"/>
-              <a:t>21</a:t>
+              <a:t>22</a:t>
             </a:fld>
             <a:endParaRPr lang="en-US"/>
           </a:p>
@@ -1425,7 +1426,7 @@
           <a:p>
             <a:fld id="{F7021451-1387-4CA6-816F-3879F97B5CBC}" type="slidenum">
               <a:rPr lang="en-US"/>
-              <a:t>23</a:t>
+              <a:t>24</a:t>
             </a:fld>
             <a:endParaRPr lang="en-US"/>
           </a:p>
@@ -1509,7 +1510,7 @@
           <a:p>
             <a:fld id="{F7021451-1387-4CA6-816F-3879F97B5CBC}" type="slidenum">
               <a:rPr lang="en-US"/>
-              <a:t>25</a:t>
+              <a:t>26</a:t>
             </a:fld>
             <a:endParaRPr lang="en-US"/>
           </a:p>
@@ -1593,7 +1594,7 @@
           <a:p>
             <a:fld id="{F7021451-1387-4CA6-816F-3879F97B5CBC}" type="slidenum">
               <a:rPr lang="en-US"/>
-              <a:t>26</a:t>
+              <a:t>27</a:t>
             </a:fld>
             <a:endParaRPr lang="en-US"/>
           </a:p>
@@ -1677,7 +1678,7 @@
           <a:p>
             <a:fld id="{F7021451-1387-4CA6-816F-3879F97B5CBC}" type="slidenum">
               <a:rPr lang="en-US"/>
-              <a:t>28</a:t>
+              <a:t>29</a:t>
             </a:fld>
             <a:endParaRPr lang="en-US"/>
           </a:p>
@@ -1761,7 +1762,7 @@
           <a:p>
             <a:fld id="{F7021451-1387-4CA6-816F-3879F97B5CBC}" type="slidenum">
               <a:rPr lang="en-US"/>
-              <a:t>29</a:t>
+              <a:t>30</a:t>
             </a:fld>
             <a:endParaRPr lang="en-US"/>
           </a:p>
@@ -1845,7 +1846,7 @@
           <a:p>
             <a:fld id="{F7021451-1387-4CA6-816F-3879F97B5CBC}" type="slidenum">
               <a:rPr lang="en-US"/>
-              <a:t>3</a:t>
+              <a:t>4</a:t>
             </a:fld>
             <a:endParaRPr lang="en-US"/>
           </a:p>
@@ -1929,7 +1930,7 @@
           <a:p>
             <a:fld id="{F7021451-1387-4CA6-816F-3879F97B5CBC}" type="slidenum">
               <a:rPr lang="en-US"/>
-              <a:t>4</a:t>
+              <a:t>5</a:t>
             </a:fld>
             <a:endParaRPr lang="en-US"/>
           </a:p>
@@ -2013,7 +2014,7 @@
           <a:p>
             <a:fld id="{F7021451-1387-4CA6-816F-3879F97B5CBC}" type="slidenum">
               <a:rPr lang="en-US"/>
-              <a:t>5</a:t>
+              <a:t>6</a:t>
             </a:fld>
             <a:endParaRPr lang="en-US"/>
           </a:p>
@@ -2097,7 +2098,7 @@
           <a:p>
             <a:fld id="{F7021451-1387-4CA6-816F-3879F97B5CBC}" type="slidenum">
               <a:rPr lang="en-US"/>
-              <a:t>6</a:t>
+              <a:t>7</a:t>
             </a:fld>
             <a:endParaRPr lang="en-US"/>
           </a:p>
@@ -2181,7 +2182,7 @@
           <a:p>
             <a:fld id="{F7021451-1387-4CA6-816F-3879F97B5CBC}" type="slidenum">
               <a:rPr lang="en-US"/>
-              <a:t>7</a:t>
+              <a:t>8</a:t>
             </a:fld>
             <a:endParaRPr lang="en-US"/>
           </a:p>
@@ -2265,7 +2266,7 @@
           <a:p>
             <a:fld id="{F7021451-1387-4CA6-816F-3879F97B5CBC}" type="slidenum">
               <a:rPr lang="en-US"/>
-              <a:t>8</a:t>
+              <a:t>9</a:t>
             </a:fld>
             <a:endParaRPr lang="en-US"/>
           </a:p>
@@ -2349,7 +2350,7 @@
           <a:p>
             <a:fld id="{F7021451-1387-4CA6-816F-3879F97B5CBC}" type="slidenum">
               <a:rPr lang="en-US"/>
-              <a:t>9</a:t>
+              <a:t>10</a:t>
             </a:fld>
             <a:endParaRPr lang="en-US"/>
           </a:p>
@@ -3297,6 +3298,1179 @@
 
 <file path=ppt/slides/slide10.xml><?xml version="1.0" encoding="utf-8"?>
 <p:sld xmlns:a="http://schemas.openxmlformats.org/drawingml/2006/main" xmlns:r="http://schemas.openxmlformats.org/officeDocument/2006/relationships" xmlns:p="http://schemas.openxmlformats.org/presentationml/2006/main">
+  <p:cSld name="Slide 10">
+    <p:bg>
+      <p:bgPr>
+        <a:solidFill>
+          <a:srgbClr val="E8F6F7"/>
+        </a:solidFill>
+        <a:effectLst/>
+      </p:bgPr>
+    </p:bg>
+    <p:spTree>
+      <p:nvGrpSpPr>
+        <p:cNvPr id="1" name=""/>
+        <p:cNvGrpSpPr/>
+        <p:nvPr/>
+      </p:nvGrpSpPr>
+      <p:grpSpPr>
+        <a:xfrm>
+          <a:off x="0" y="0"/>
+          <a:ext cx="0" cy="0"/>
+          <a:chOff x="0" y="0"/>
+          <a:chExt cx="0" cy="0"/>
+        </a:xfrm>
+      </p:grpSpPr>
+      <p:sp>
+        <p:nvSpPr>
+          <p:cNvPr id="2" name="Text 0"/>
+          <p:cNvSpPr/>
+          <p:nvPr/>
+        </p:nvSpPr>
+        <p:spPr>
+          <a:xfrm>
+            <a:off x="11018520" y="6263640"/>
+            <a:ext cx="548640" cy="274320"/>
+          </a:xfrm>
+          <a:prstGeom prst="rect">
+            <a:avLst/>
+          </a:prstGeom>
+          <a:noFill/>
+          <a:ln/>
+        </p:spPr>
+        <p:txBody>
+          <a:bodyPr wrap="square" lIns="0" tIns="0" rIns="0" bIns="0" rtlCol="0" anchor="ctr"/>
+          <a:lstStyle/>
+          <a:p>
+            <a:pPr marL="0" indent="0" algn="r">
+              <a:buNone/>
+            </a:pPr>
+            <a:r>
+              <a:rPr lang="en-US" sz="1200" dirty="0">
+                <a:solidFill>
+                  <a:srgbClr val="9AA3AD"/>
+                </a:solidFill>
+                <a:latin typeface="TH Sarabun New" pitchFamily="34" charset="0"/>
+                <a:ea typeface="TH Sarabun New" pitchFamily="34" charset="-122"/>
+                <a:cs typeface="TH Sarabun New" pitchFamily="34" charset="-120"/>
+              </a:rPr>
+              <a:t>10</a:t>
+            </a:r>
+            <a:endParaRPr lang="en-US" sz="1200" dirty="0"/>
+          </a:p>
+        </p:txBody>
+      </p:sp>
+      <p:sp>
+        <p:nvSpPr>
+          <p:cNvPr id="3" name="Shape 1"/>
+          <p:cNvSpPr/>
+          <p:nvPr/>
+        </p:nvSpPr>
+        <p:spPr>
+          <a:xfrm>
+            <a:off x="594360" y="310896"/>
+            <a:ext cx="1481328" cy="475488"/>
+          </a:xfrm>
+          <a:prstGeom prst="roundRect">
+            <a:avLst>
+              <a:gd name="adj" fmla="val 50000"/>
+            </a:avLst>
+          </a:prstGeom>
+          <a:solidFill>
+            <a:srgbClr val="00ADB5"/>
+          </a:solidFill>
+          <a:ln w="12700">
+            <a:solidFill>
+              <a:srgbClr val="00ADB5"/>
+            </a:solidFill>
+            <a:prstDash val="solid"/>
+          </a:ln>
+        </p:spPr>
+        <p:txBody>
+          <a:bodyPr/>
+          <a:lstStyle/>
+          <a:p>
+            <a:endParaRPr lang="en-TH"/>
+          </a:p>
+        </p:txBody>
+      </p:sp>
+      <p:sp>
+        <p:nvSpPr>
+          <p:cNvPr id="4" name="Text 2"/>
+          <p:cNvSpPr/>
+          <p:nvPr/>
+        </p:nvSpPr>
+        <p:spPr>
+          <a:xfrm>
+            <a:off x="594360" y="310896"/>
+            <a:ext cx="1481328" cy="475488"/>
+          </a:xfrm>
+          <a:prstGeom prst="rect">
+            <a:avLst/>
+          </a:prstGeom>
+          <a:noFill/>
+          <a:ln/>
+        </p:spPr>
+        <p:txBody>
+          <a:bodyPr wrap="square" lIns="0" tIns="0" rIns="0" bIns="0" rtlCol="0" anchor="ctr"/>
+          <a:lstStyle/>
+          <a:p>
+            <a:pPr marL="0" indent="0" algn="ctr">
+              <a:buNone/>
+            </a:pPr>
+            <a:r>
+              <a:rPr lang="en-US" sz="1800" b="1" dirty="0">
+                <a:solidFill>
+                  <a:srgbClr val="FFFFFF"/>
+                </a:solidFill>
+                <a:latin typeface="TH Sarabun New" pitchFamily="34" charset="0"/>
+                <a:ea typeface="TH Sarabun New" pitchFamily="34" charset="-122"/>
+                <a:cs typeface="TH Sarabun New" pitchFamily="34" charset="-120"/>
+              </a:rPr>
+              <a:t>LAB A</a:t>
+            </a:r>
+            <a:endParaRPr lang="en-US" sz="1800" dirty="0"/>
+          </a:p>
+        </p:txBody>
+      </p:sp>
+      <p:sp>
+        <p:nvSpPr>
+          <p:cNvPr id="5" name="Text 3"/>
+          <p:cNvSpPr/>
+          <p:nvPr/>
+        </p:nvSpPr>
+        <p:spPr>
+          <a:xfrm>
+            <a:off x="2286000" y="274320"/>
+            <a:ext cx="7315200" cy="548640"/>
+          </a:xfrm>
+          <a:prstGeom prst="rect">
+            <a:avLst/>
+          </a:prstGeom>
+          <a:noFill/>
+          <a:ln/>
+        </p:spPr>
+        <p:txBody>
+          <a:bodyPr wrap="square" lIns="0" tIns="0" rIns="0" bIns="0" rtlCol="0" anchor="ctr"/>
+          <a:lstStyle/>
+          <a:p>
+            <a:pPr marL="0" indent="0">
+              <a:buNone/>
+            </a:pPr>
+            <a:r>
+              <a:rPr lang="en-US" sz="3000" b="1" dirty="0">
+                <a:solidFill>
+                  <a:srgbClr val="222831"/>
+                </a:solidFill>
+                <a:latin typeface="TH Sarabun New" pitchFamily="34" charset="0"/>
+                <a:ea typeface="TH Sarabun New" pitchFamily="34" charset="-122"/>
+                <a:cs typeface="TH Sarabun New" pitchFamily="34" charset="-120"/>
+              </a:rPr>
+              <a:t>เตรียมเครื่องและเปิดโปรเจกต์</a:t>
+            </a:r>
+            <a:endParaRPr lang="en-US" sz="3000" dirty="0"/>
+          </a:p>
+        </p:txBody>
+      </p:sp>
+      <p:sp>
+        <p:nvSpPr>
+          <p:cNvPr id="6" name="Text 4"/>
+          <p:cNvSpPr/>
+          <p:nvPr/>
+        </p:nvSpPr>
+        <p:spPr>
+          <a:xfrm>
+            <a:off x="9738360" y="310896"/>
+            <a:ext cx="1828800" cy="475488"/>
+          </a:xfrm>
+          <a:prstGeom prst="rect">
+            <a:avLst/>
+          </a:prstGeom>
+          <a:noFill/>
+          <a:ln/>
+        </p:spPr>
+        <p:txBody>
+          <a:bodyPr wrap="square" lIns="0" tIns="0" rIns="0" bIns="0" rtlCol="0" anchor="ctr"/>
+          <a:lstStyle/>
+          <a:p>
+            <a:pPr marL="0" indent="0" algn="r">
+              <a:buNone/>
+            </a:pPr>
+            <a:r>
+              <a:rPr lang="en-US" sz="1700" dirty="0">
+                <a:solidFill>
+                  <a:srgbClr val="393E46"/>
+                </a:solidFill>
+                <a:latin typeface="TH Sarabun New" pitchFamily="34" charset="0"/>
+                <a:ea typeface="TH Sarabun New" pitchFamily="34" charset="-122"/>
+                <a:cs typeface="TH Sarabun New" pitchFamily="34" charset="-120"/>
+              </a:rPr>
+              <a:t>10 นาที</a:t>
+            </a:r>
+            <a:endParaRPr lang="en-US" sz="1700" dirty="0"/>
+          </a:p>
+        </p:txBody>
+      </p:sp>
+      <p:sp>
+        <p:nvSpPr>
+          <p:cNvPr id="7" name="Shape 5"/>
+          <p:cNvSpPr/>
+          <p:nvPr/>
+        </p:nvSpPr>
+        <p:spPr>
+          <a:xfrm>
+            <a:off x="594360" y="1024128"/>
+            <a:ext cx="5760720" cy="3794760"/>
+          </a:xfrm>
+          <a:prstGeom prst="roundRect">
+            <a:avLst>
+              <a:gd name="adj" fmla="val 2169"/>
+            </a:avLst>
+          </a:prstGeom>
+          <a:solidFill>
+            <a:srgbClr val="FFFFFF"/>
+          </a:solidFill>
+          <a:ln w="9525">
+            <a:solidFill>
+              <a:srgbClr val="FFFFFF"/>
+            </a:solidFill>
+            <a:prstDash val="solid"/>
+          </a:ln>
+          <a:effectLst>
+            <a:outerShdw blurRad="101600" dist="12700" dir="5400000" algn="bl" rotWithShape="0">
+              <a:srgbClr val="222831">
+                <a:alpha val="10000"/>
+              </a:srgbClr>
+            </a:outerShdw>
+          </a:effectLst>
+        </p:spPr>
+        <p:txBody>
+          <a:bodyPr/>
+          <a:lstStyle/>
+          <a:p>
+            <a:endParaRPr lang="en-TH"/>
+          </a:p>
+        </p:txBody>
+      </p:sp>
+      <p:sp>
+        <p:nvSpPr>
+          <p:cNvPr id="8" name="Text 6"/>
+          <p:cNvSpPr/>
+          <p:nvPr/>
+        </p:nvSpPr>
+        <p:spPr>
+          <a:xfrm>
+            <a:off x="850392" y="1188720"/>
+            <a:ext cx="5248656" cy="310896"/>
+          </a:xfrm>
+          <a:prstGeom prst="rect">
+            <a:avLst/>
+          </a:prstGeom>
+          <a:noFill/>
+          <a:ln/>
+        </p:spPr>
+        <p:txBody>
+          <a:bodyPr wrap="square" lIns="0" tIns="0" rIns="0" bIns="0" rtlCol="0" anchor="ctr"/>
+          <a:lstStyle/>
+          <a:p>
+            <a:pPr marL="0" indent="0">
+              <a:buNone/>
+            </a:pPr>
+            <a:r>
+              <a:rPr lang="en-US" sz="1900" b="1" dirty="0">
+                <a:solidFill>
+                  <a:srgbClr val="222831"/>
+                </a:solidFill>
+                <a:latin typeface="TH Sarabun New" pitchFamily="34" charset="0"/>
+                <a:ea typeface="TH Sarabun New" pitchFamily="34" charset="-122"/>
+                <a:cs typeface="TH Sarabun New" pitchFamily="34" charset="-120"/>
+              </a:rPr>
+              <a:t>สิ่งที่ต้องทำ</a:t>
+            </a:r>
+            <a:endParaRPr lang="en-US" sz="1900" dirty="0"/>
+          </a:p>
+        </p:txBody>
+      </p:sp>
+      <p:sp>
+        <p:nvSpPr>
+          <p:cNvPr id="9" name="Shape 7"/>
+          <p:cNvSpPr/>
+          <p:nvPr/>
+        </p:nvSpPr>
+        <p:spPr>
+          <a:xfrm>
+            <a:off x="868680" y="1636776"/>
+            <a:ext cx="329184" cy="329184"/>
+          </a:xfrm>
+          <a:prstGeom prst="ellipse">
+            <a:avLst/>
+          </a:prstGeom>
+          <a:solidFill>
+            <a:srgbClr val="00ADB5"/>
+          </a:solidFill>
+          <a:ln w="12700">
+            <a:solidFill>
+              <a:srgbClr val="00ADB5"/>
+            </a:solidFill>
+            <a:prstDash val="solid"/>
+          </a:ln>
+        </p:spPr>
+        <p:txBody>
+          <a:bodyPr/>
+          <a:lstStyle/>
+          <a:p>
+            <a:endParaRPr lang="en-TH"/>
+          </a:p>
+        </p:txBody>
+      </p:sp>
+      <p:sp>
+        <p:nvSpPr>
+          <p:cNvPr id="10" name="Text 8"/>
+          <p:cNvSpPr/>
+          <p:nvPr/>
+        </p:nvSpPr>
+        <p:spPr>
+          <a:xfrm>
+            <a:off x="868680" y="1636776"/>
+            <a:ext cx="329184" cy="329184"/>
+          </a:xfrm>
+          <a:prstGeom prst="rect">
+            <a:avLst/>
+          </a:prstGeom>
+          <a:noFill/>
+          <a:ln/>
+        </p:spPr>
+        <p:txBody>
+          <a:bodyPr wrap="square" lIns="0" tIns="0" rIns="0" bIns="0" rtlCol="0" anchor="ctr"/>
+          <a:lstStyle/>
+          <a:p>
+            <a:pPr marL="0" indent="0" algn="ctr">
+              <a:buNone/>
+            </a:pPr>
+            <a:r>
+              <a:rPr lang="en-US" sz="1500" b="1" dirty="0">
+                <a:solidFill>
+                  <a:srgbClr val="FFFFFF"/>
+                </a:solidFill>
+                <a:latin typeface="TH Sarabun New" pitchFamily="34" charset="0"/>
+                <a:ea typeface="TH Sarabun New" pitchFamily="34" charset="-122"/>
+                <a:cs typeface="TH Sarabun New" pitchFamily="34" charset="-120"/>
+              </a:rPr>
+              <a:t>1</a:t>
+            </a:r>
+            <a:endParaRPr lang="en-US" sz="1500" dirty="0"/>
+          </a:p>
+        </p:txBody>
+      </p:sp>
+      <p:sp>
+        <p:nvSpPr>
+          <p:cNvPr id="11" name="Text 9"/>
+          <p:cNvSpPr/>
+          <p:nvPr/>
+        </p:nvSpPr>
+        <p:spPr>
+          <a:xfrm>
+            <a:off x="1307592" y="1572768"/>
+            <a:ext cx="4754880" cy="457200"/>
+          </a:xfrm>
+          <a:prstGeom prst="rect">
+            <a:avLst/>
+          </a:prstGeom>
+          <a:noFill/>
+          <a:ln/>
+        </p:spPr>
+        <p:txBody>
+          <a:bodyPr wrap="square" lIns="0" tIns="0" rIns="0" bIns="0" rtlCol="0" anchor="ctr"/>
+          <a:lstStyle/>
+          <a:p>
+            <a:pPr marL="0" indent="0">
+              <a:buNone/>
+            </a:pPr>
+            <a:r>
+              <a:rPr lang="en-US" sz="1600" dirty="0">
+                <a:solidFill>
+                  <a:srgbClr val="393E46"/>
+                </a:solidFill>
+                <a:latin typeface="TH Sarabun New" pitchFamily="34" charset="0"/>
+                <a:ea typeface="TH Sarabun New" pitchFamily="34" charset="-122"/>
+                <a:cs typeface="TH Sarabun New" pitchFamily="34" charset="-120"/>
+              </a:rPr>
+              <a:t>ตรวจว่ามี Node.js, Git และ Antigravity IDE แล้ว</a:t>
+            </a:r>
+            <a:endParaRPr lang="en-US" sz="1600" dirty="0"/>
+          </a:p>
+        </p:txBody>
+      </p:sp>
+      <p:sp>
+        <p:nvSpPr>
+          <p:cNvPr id="12" name="Shape 10"/>
+          <p:cNvSpPr/>
+          <p:nvPr/>
+        </p:nvSpPr>
+        <p:spPr>
+          <a:xfrm>
+            <a:off x="868680" y="2221992"/>
+            <a:ext cx="329184" cy="329184"/>
+          </a:xfrm>
+          <a:prstGeom prst="ellipse">
+            <a:avLst/>
+          </a:prstGeom>
+          <a:solidFill>
+            <a:srgbClr val="00ADB5"/>
+          </a:solidFill>
+          <a:ln w="12700">
+            <a:solidFill>
+              <a:srgbClr val="00ADB5"/>
+            </a:solidFill>
+            <a:prstDash val="solid"/>
+          </a:ln>
+        </p:spPr>
+        <p:txBody>
+          <a:bodyPr/>
+          <a:lstStyle/>
+          <a:p>
+            <a:endParaRPr lang="en-TH"/>
+          </a:p>
+        </p:txBody>
+      </p:sp>
+      <p:sp>
+        <p:nvSpPr>
+          <p:cNvPr id="13" name="Text 11"/>
+          <p:cNvSpPr/>
+          <p:nvPr/>
+        </p:nvSpPr>
+        <p:spPr>
+          <a:xfrm>
+            <a:off x="868680" y="2221992"/>
+            <a:ext cx="329184" cy="329184"/>
+          </a:xfrm>
+          <a:prstGeom prst="rect">
+            <a:avLst/>
+          </a:prstGeom>
+          <a:noFill/>
+          <a:ln/>
+        </p:spPr>
+        <p:txBody>
+          <a:bodyPr wrap="square" lIns="0" tIns="0" rIns="0" bIns="0" rtlCol="0" anchor="ctr"/>
+          <a:lstStyle/>
+          <a:p>
+            <a:pPr marL="0" indent="0" algn="ctr">
+              <a:buNone/>
+            </a:pPr>
+            <a:r>
+              <a:rPr lang="en-US" sz="1500" b="1" dirty="0">
+                <a:solidFill>
+                  <a:srgbClr val="FFFFFF"/>
+                </a:solidFill>
+                <a:latin typeface="TH Sarabun New" pitchFamily="34" charset="0"/>
+                <a:ea typeface="TH Sarabun New" pitchFamily="34" charset="-122"/>
+                <a:cs typeface="TH Sarabun New" pitchFamily="34" charset="-120"/>
+              </a:rPr>
+              <a:t>2</a:t>
+            </a:r>
+            <a:endParaRPr lang="en-US" sz="1500" dirty="0"/>
+          </a:p>
+        </p:txBody>
+      </p:sp>
+      <p:sp>
+        <p:nvSpPr>
+          <p:cNvPr id="14" name="Text 12"/>
+          <p:cNvSpPr/>
+          <p:nvPr/>
+        </p:nvSpPr>
+        <p:spPr>
+          <a:xfrm>
+            <a:off x="1307592" y="2157984"/>
+            <a:ext cx="4754880" cy="457200"/>
+          </a:xfrm>
+          <a:prstGeom prst="rect">
+            <a:avLst/>
+          </a:prstGeom>
+          <a:noFill/>
+          <a:ln/>
+        </p:spPr>
+        <p:txBody>
+          <a:bodyPr wrap="square" lIns="0" tIns="0" rIns="0" bIns="0" rtlCol="0" anchor="ctr"/>
+          <a:lstStyle/>
+          <a:p>
+            <a:pPr marL="0" indent="0">
+              <a:buNone/>
+            </a:pPr>
+            <a:r>
+              <a:rPr lang="en-US" sz="1600" dirty="0">
+                <a:solidFill>
+                  <a:srgbClr val="393E46"/>
+                </a:solidFill>
+                <a:latin typeface="TH Sarabun New" pitchFamily="34" charset="0"/>
+                <a:ea typeface="TH Sarabun New" pitchFamily="34" charset="-122"/>
+                <a:cs typeface="TH Sarabun New" pitchFamily="34" charset="-120"/>
+              </a:rPr>
+              <a:t>สร้างโฟลเดอร์ fundinghub แล้วเปิดใน Antigravity</a:t>
+            </a:r>
+            <a:endParaRPr lang="en-US" sz="1600" dirty="0"/>
+          </a:p>
+        </p:txBody>
+      </p:sp>
+      <p:sp>
+        <p:nvSpPr>
+          <p:cNvPr id="15" name="Shape 13"/>
+          <p:cNvSpPr/>
+          <p:nvPr/>
+        </p:nvSpPr>
+        <p:spPr>
+          <a:xfrm>
+            <a:off x="868680" y="2807208"/>
+            <a:ext cx="329184" cy="329184"/>
+          </a:xfrm>
+          <a:prstGeom prst="ellipse">
+            <a:avLst/>
+          </a:prstGeom>
+          <a:solidFill>
+            <a:srgbClr val="00ADB5"/>
+          </a:solidFill>
+          <a:ln w="12700">
+            <a:solidFill>
+              <a:srgbClr val="00ADB5"/>
+            </a:solidFill>
+            <a:prstDash val="solid"/>
+          </a:ln>
+        </p:spPr>
+        <p:txBody>
+          <a:bodyPr/>
+          <a:lstStyle/>
+          <a:p>
+            <a:endParaRPr lang="en-TH"/>
+          </a:p>
+        </p:txBody>
+      </p:sp>
+      <p:sp>
+        <p:nvSpPr>
+          <p:cNvPr id="16" name="Text 14"/>
+          <p:cNvSpPr/>
+          <p:nvPr/>
+        </p:nvSpPr>
+        <p:spPr>
+          <a:xfrm>
+            <a:off x="868680" y="2807208"/>
+            <a:ext cx="329184" cy="329184"/>
+          </a:xfrm>
+          <a:prstGeom prst="rect">
+            <a:avLst/>
+          </a:prstGeom>
+          <a:noFill/>
+          <a:ln/>
+        </p:spPr>
+        <p:txBody>
+          <a:bodyPr wrap="square" lIns="0" tIns="0" rIns="0" bIns="0" rtlCol="0" anchor="ctr"/>
+          <a:lstStyle/>
+          <a:p>
+            <a:pPr marL="0" indent="0" algn="ctr">
+              <a:buNone/>
+            </a:pPr>
+            <a:r>
+              <a:rPr lang="en-US" sz="1500" b="1" dirty="0">
+                <a:solidFill>
+                  <a:srgbClr val="FFFFFF"/>
+                </a:solidFill>
+                <a:latin typeface="TH Sarabun New" pitchFamily="34" charset="0"/>
+                <a:ea typeface="TH Sarabun New" pitchFamily="34" charset="-122"/>
+                <a:cs typeface="TH Sarabun New" pitchFamily="34" charset="-120"/>
+              </a:rPr>
+              <a:t>3</a:t>
+            </a:r>
+            <a:endParaRPr lang="en-US" sz="1500" dirty="0"/>
+          </a:p>
+        </p:txBody>
+      </p:sp>
+      <p:sp>
+        <p:nvSpPr>
+          <p:cNvPr id="17" name="Text 15"/>
+          <p:cNvSpPr/>
+          <p:nvPr/>
+        </p:nvSpPr>
+        <p:spPr>
+          <a:xfrm>
+            <a:off x="1307592" y="2743200"/>
+            <a:ext cx="4754880" cy="457200"/>
+          </a:xfrm>
+          <a:prstGeom prst="rect">
+            <a:avLst/>
+          </a:prstGeom>
+          <a:noFill/>
+          <a:ln/>
+        </p:spPr>
+        <p:txBody>
+          <a:bodyPr wrap="square" lIns="0" tIns="0" rIns="0" bIns="0" rtlCol="0" anchor="ctr"/>
+          <a:lstStyle/>
+          <a:p>
+            <a:pPr marL="0" indent="0">
+              <a:buNone/>
+            </a:pPr>
+            <a:r>
+              <a:rPr lang="en-US" sz="1600" dirty="0">
+                <a:solidFill>
+                  <a:srgbClr val="393E46"/>
+                </a:solidFill>
+                <a:latin typeface="TH Sarabun New" pitchFamily="34" charset="0"/>
+                <a:ea typeface="TH Sarabun New" pitchFamily="34" charset="-122"/>
+                <a:cs typeface="TH Sarabun New" pitchFamily="34" charset="-120"/>
+              </a:rPr>
+              <a:t>สร้างไฟล์เปล่าชื่อ SPEC_FundingHub.md ที่รากโปรเจกต์</a:t>
+            </a:r>
+            <a:endParaRPr lang="en-US" sz="1600" dirty="0"/>
+          </a:p>
+        </p:txBody>
+      </p:sp>
+      <p:sp>
+        <p:nvSpPr>
+          <p:cNvPr id="18" name="Shape 16"/>
+          <p:cNvSpPr/>
+          <p:nvPr/>
+        </p:nvSpPr>
+        <p:spPr>
+          <a:xfrm>
+            <a:off x="868680" y="3392424"/>
+            <a:ext cx="329184" cy="329184"/>
+          </a:xfrm>
+          <a:prstGeom prst="ellipse">
+            <a:avLst/>
+          </a:prstGeom>
+          <a:solidFill>
+            <a:srgbClr val="00ADB5"/>
+          </a:solidFill>
+          <a:ln w="12700">
+            <a:solidFill>
+              <a:srgbClr val="00ADB5"/>
+            </a:solidFill>
+            <a:prstDash val="solid"/>
+          </a:ln>
+        </p:spPr>
+        <p:txBody>
+          <a:bodyPr/>
+          <a:lstStyle/>
+          <a:p>
+            <a:endParaRPr lang="en-TH"/>
+          </a:p>
+        </p:txBody>
+      </p:sp>
+      <p:sp>
+        <p:nvSpPr>
+          <p:cNvPr id="19" name="Text 17"/>
+          <p:cNvSpPr/>
+          <p:nvPr/>
+        </p:nvSpPr>
+        <p:spPr>
+          <a:xfrm>
+            <a:off x="868680" y="3392424"/>
+            <a:ext cx="329184" cy="329184"/>
+          </a:xfrm>
+          <a:prstGeom prst="rect">
+            <a:avLst/>
+          </a:prstGeom>
+          <a:noFill/>
+          <a:ln/>
+        </p:spPr>
+        <p:txBody>
+          <a:bodyPr wrap="square" lIns="0" tIns="0" rIns="0" bIns="0" rtlCol="0" anchor="ctr"/>
+          <a:lstStyle/>
+          <a:p>
+            <a:pPr marL="0" indent="0" algn="ctr">
+              <a:buNone/>
+            </a:pPr>
+            <a:r>
+              <a:rPr lang="en-US" sz="1500" b="1" dirty="0">
+                <a:solidFill>
+                  <a:srgbClr val="FFFFFF"/>
+                </a:solidFill>
+                <a:latin typeface="TH Sarabun New" pitchFamily="34" charset="0"/>
+                <a:ea typeface="TH Sarabun New" pitchFamily="34" charset="-122"/>
+                <a:cs typeface="TH Sarabun New" pitchFamily="34" charset="-120"/>
+              </a:rPr>
+              <a:t>4</a:t>
+            </a:r>
+            <a:endParaRPr lang="en-US" sz="1500" dirty="0"/>
+          </a:p>
+        </p:txBody>
+      </p:sp>
+      <p:sp>
+        <p:nvSpPr>
+          <p:cNvPr id="20" name="Text 18"/>
+          <p:cNvSpPr/>
+          <p:nvPr/>
+        </p:nvSpPr>
+        <p:spPr>
+          <a:xfrm>
+            <a:off x="1307592" y="3328416"/>
+            <a:ext cx="4754880" cy="457200"/>
+          </a:xfrm>
+          <a:prstGeom prst="rect">
+            <a:avLst/>
+          </a:prstGeom>
+          <a:noFill/>
+          <a:ln/>
+        </p:spPr>
+        <p:txBody>
+          <a:bodyPr wrap="square" lIns="0" tIns="0" rIns="0" bIns="0" rtlCol="0" anchor="ctr"/>
+          <a:lstStyle/>
+          <a:p>
+            <a:pPr marL="0" indent="0">
+              <a:buNone/>
+            </a:pPr>
+            <a:r>
+              <a:rPr lang="en-US" sz="1600" dirty="0">
+                <a:solidFill>
+                  <a:srgbClr val="393E46"/>
+                </a:solidFill>
+                <a:latin typeface="TH Sarabun New" pitchFamily="34" charset="0"/>
+                <a:ea typeface="TH Sarabun New" pitchFamily="34" charset="-122"/>
+                <a:cs typeface="TH Sarabun New" pitchFamily="34" charset="-120"/>
+              </a:rPr>
+              <a:t>เปิดไฟล์ SPEC_BLOCKS.md ที่แจกให้ ไว้อีกหน้าต่างหนึ่ง</a:t>
+            </a:r>
+            <a:endParaRPr lang="en-US" sz="1600" dirty="0"/>
+          </a:p>
+        </p:txBody>
+      </p:sp>
+      <p:sp>
+        <p:nvSpPr>
+          <p:cNvPr id="21" name="Shape 19"/>
+          <p:cNvSpPr/>
+          <p:nvPr/>
+        </p:nvSpPr>
+        <p:spPr>
+          <a:xfrm>
+            <a:off x="868680" y="3977640"/>
+            <a:ext cx="329184" cy="329184"/>
+          </a:xfrm>
+          <a:prstGeom prst="ellipse">
+            <a:avLst/>
+          </a:prstGeom>
+          <a:solidFill>
+            <a:srgbClr val="00ADB5"/>
+          </a:solidFill>
+          <a:ln w="12700">
+            <a:solidFill>
+              <a:srgbClr val="00ADB5"/>
+            </a:solidFill>
+            <a:prstDash val="solid"/>
+          </a:ln>
+        </p:spPr>
+        <p:txBody>
+          <a:bodyPr/>
+          <a:lstStyle/>
+          <a:p>
+            <a:endParaRPr lang="en-TH"/>
+          </a:p>
+        </p:txBody>
+      </p:sp>
+      <p:sp>
+        <p:nvSpPr>
+          <p:cNvPr id="22" name="Text 20"/>
+          <p:cNvSpPr/>
+          <p:nvPr/>
+        </p:nvSpPr>
+        <p:spPr>
+          <a:xfrm>
+            <a:off x="868680" y="3977640"/>
+            <a:ext cx="329184" cy="329184"/>
+          </a:xfrm>
+          <a:prstGeom prst="rect">
+            <a:avLst/>
+          </a:prstGeom>
+          <a:noFill/>
+          <a:ln/>
+        </p:spPr>
+        <p:txBody>
+          <a:bodyPr wrap="square" lIns="0" tIns="0" rIns="0" bIns="0" rtlCol="0" anchor="ctr"/>
+          <a:lstStyle/>
+          <a:p>
+            <a:pPr marL="0" indent="0" algn="ctr">
+              <a:buNone/>
+            </a:pPr>
+            <a:r>
+              <a:rPr lang="en-US" sz="1500" b="1" dirty="0">
+                <a:solidFill>
+                  <a:srgbClr val="FFFFFF"/>
+                </a:solidFill>
+                <a:latin typeface="TH Sarabun New" pitchFamily="34" charset="0"/>
+                <a:ea typeface="TH Sarabun New" pitchFamily="34" charset="-122"/>
+                <a:cs typeface="TH Sarabun New" pitchFamily="34" charset="-120"/>
+              </a:rPr>
+              <a:t>5</a:t>
+            </a:r>
+            <a:endParaRPr lang="en-US" sz="1500" dirty="0"/>
+          </a:p>
+        </p:txBody>
+      </p:sp>
+      <p:sp>
+        <p:nvSpPr>
+          <p:cNvPr id="23" name="Text 21"/>
+          <p:cNvSpPr/>
+          <p:nvPr/>
+        </p:nvSpPr>
+        <p:spPr>
+          <a:xfrm>
+            <a:off x="1307592" y="3913632"/>
+            <a:ext cx="4754880" cy="457200"/>
+          </a:xfrm>
+          <a:prstGeom prst="rect">
+            <a:avLst/>
+          </a:prstGeom>
+          <a:noFill/>
+          <a:ln/>
+        </p:spPr>
+        <p:txBody>
+          <a:bodyPr wrap="square" lIns="0" tIns="0" rIns="0" bIns="0" rtlCol="0" anchor="ctr"/>
+          <a:lstStyle/>
+          <a:p>
+            <a:pPr marL="0" indent="0">
+              <a:buNone/>
+            </a:pPr>
+            <a:r>
+              <a:rPr lang="en-US" sz="1600" dirty="0">
+                <a:solidFill>
+                  <a:srgbClr val="393E46"/>
+                </a:solidFill>
+                <a:latin typeface="TH Sarabun New" pitchFamily="34" charset="0"/>
+                <a:ea typeface="TH Sarabun New" pitchFamily="34" charset="-122"/>
+                <a:cs typeface="TH Sarabun New" pitchFamily="34" charset="-120"/>
+              </a:rPr>
+              <a:t>หาให้เจอ 4 ส่วน : Editor / Agent / Artifacts / Browser</a:t>
+            </a:r>
+            <a:endParaRPr lang="en-US" sz="1600" dirty="0"/>
+          </a:p>
+        </p:txBody>
+      </p:sp>
+      <p:sp>
+        <p:nvSpPr>
+          <p:cNvPr id="24" name="Shape 22"/>
+          <p:cNvSpPr/>
+          <p:nvPr/>
+        </p:nvSpPr>
+        <p:spPr>
+          <a:xfrm>
+            <a:off x="6583680" y="1024128"/>
+            <a:ext cx="4983480" cy="1600200"/>
+          </a:xfrm>
+          <a:prstGeom prst="roundRect">
+            <a:avLst>
+              <a:gd name="adj" fmla="val 4000"/>
+            </a:avLst>
+          </a:prstGeom>
+          <a:solidFill>
+            <a:srgbClr val="222831"/>
+          </a:solidFill>
+          <a:ln w="12700">
+            <a:solidFill>
+              <a:srgbClr val="222831"/>
+            </a:solidFill>
+            <a:prstDash val="solid"/>
+          </a:ln>
+        </p:spPr>
+        <p:txBody>
+          <a:bodyPr/>
+          <a:lstStyle/>
+          <a:p>
+            <a:endParaRPr lang="en-TH"/>
+          </a:p>
+        </p:txBody>
+      </p:sp>
+      <p:sp>
+        <p:nvSpPr>
+          <p:cNvPr id="25" name="Text 23"/>
+          <p:cNvSpPr/>
+          <p:nvPr/>
+        </p:nvSpPr>
+        <p:spPr>
+          <a:xfrm>
+            <a:off x="6729984" y="1115568"/>
+            <a:ext cx="4690872" cy="1417320"/>
+          </a:xfrm>
+          <a:prstGeom prst="rect">
+            <a:avLst/>
+          </a:prstGeom>
+          <a:noFill/>
+          <a:ln/>
+        </p:spPr>
+        <p:txBody>
+          <a:bodyPr wrap="square" lIns="0" tIns="0" rIns="0" bIns="0" rtlCol="0" anchor="t"/>
+          <a:lstStyle/>
+          <a:p>
+            <a:pPr marL="0" indent="0">
+              <a:lnSpc>
+                <a:spcPts val="1700"/>
+              </a:lnSpc>
+              <a:buNone/>
+            </a:pPr>
+            <a:r>
+              <a:rPr lang="en-US" sz="1150" dirty="0">
+                <a:solidFill>
+                  <a:srgbClr val="D6F5F7"/>
+                </a:solidFill>
+                <a:latin typeface="Courier New" pitchFamily="34" charset="0"/>
+                <a:ea typeface="Courier New" pitchFamily="34" charset="-122"/>
+                <a:cs typeface="Courier New" pitchFamily="34" charset="-120"/>
+              </a:rPr>
+              <a:t>node -v</a:t>
+            </a:r>
+            <a:endParaRPr lang="en-US" sz="1150" dirty="0"/>
+          </a:p>
+          <a:p>
+            <a:pPr marL="0" indent="0">
+              <a:lnSpc>
+                <a:spcPts val="1700"/>
+              </a:lnSpc>
+              <a:buNone/>
+            </a:pPr>
+            <a:r>
+              <a:rPr lang="en-US" sz="1150" dirty="0">
+                <a:solidFill>
+                  <a:srgbClr val="D6F5F7"/>
+                </a:solidFill>
+                <a:latin typeface="Courier New" pitchFamily="34" charset="0"/>
+                <a:ea typeface="Courier New" pitchFamily="34" charset="-122"/>
+                <a:cs typeface="Courier New" pitchFamily="34" charset="-120"/>
+              </a:rPr>
+              <a:t>npm -v</a:t>
+            </a:r>
+            <a:endParaRPr lang="en-US" sz="1150" dirty="0"/>
+          </a:p>
+          <a:p>
+            <a:pPr marL="0" indent="0">
+              <a:lnSpc>
+                <a:spcPts val="1700"/>
+              </a:lnSpc>
+              <a:buNone/>
+            </a:pPr>
+            <a:r>
+              <a:rPr lang="en-US" sz="1150" dirty="0">
+                <a:solidFill>
+                  <a:srgbClr val="D6F5F7"/>
+                </a:solidFill>
+                <a:latin typeface="Courier New" pitchFamily="34" charset="0"/>
+                <a:ea typeface="Courier New" pitchFamily="34" charset="-122"/>
+                <a:cs typeface="Courier New" pitchFamily="34" charset="-120"/>
+              </a:rPr>
+              <a:t>git --version</a:t>
+            </a:r>
+            <a:endParaRPr lang="en-US" sz="1150" dirty="0"/>
+          </a:p>
+        </p:txBody>
+      </p:sp>
+      <p:sp>
+        <p:nvSpPr>
+          <p:cNvPr id="26" name="Shape 24"/>
+          <p:cNvSpPr/>
+          <p:nvPr/>
+        </p:nvSpPr>
+        <p:spPr>
+          <a:xfrm>
+            <a:off x="6583680" y="2788920"/>
+            <a:ext cx="4983480" cy="2029968"/>
+          </a:xfrm>
+          <a:prstGeom prst="roundRect">
+            <a:avLst>
+              <a:gd name="adj" fmla="val 4054"/>
+            </a:avLst>
+          </a:prstGeom>
+          <a:solidFill>
+            <a:srgbClr val="FFFFFF"/>
+          </a:solidFill>
+          <a:ln w="9525">
+            <a:solidFill>
+              <a:srgbClr val="FFFFFF"/>
+            </a:solidFill>
+            <a:prstDash val="solid"/>
+          </a:ln>
+          <a:effectLst>
+            <a:outerShdw blurRad="101600" dist="12700" dir="5400000" algn="bl" rotWithShape="0">
+              <a:srgbClr val="222831">
+                <a:alpha val="10000"/>
+              </a:srgbClr>
+            </a:outerShdw>
+          </a:effectLst>
+        </p:spPr>
+        <p:txBody>
+          <a:bodyPr/>
+          <a:lstStyle/>
+          <a:p>
+            <a:endParaRPr lang="en-TH"/>
+          </a:p>
+        </p:txBody>
+      </p:sp>
+      <p:sp>
+        <p:nvSpPr>
+          <p:cNvPr id="27" name="Text 25"/>
+          <p:cNvSpPr/>
+          <p:nvPr/>
+        </p:nvSpPr>
+        <p:spPr>
+          <a:xfrm>
+            <a:off x="6812280" y="2926080"/>
+            <a:ext cx="4526280" cy="310896"/>
+          </a:xfrm>
+          <a:prstGeom prst="rect">
+            <a:avLst/>
+          </a:prstGeom>
+          <a:noFill/>
+          <a:ln/>
+        </p:spPr>
+        <p:txBody>
+          <a:bodyPr wrap="square" lIns="0" tIns="0" rIns="0" bIns="0" rtlCol="0" anchor="ctr"/>
+          <a:lstStyle/>
+          <a:p>
+            <a:pPr marL="0" indent="0">
+              <a:buNone/>
+            </a:pPr>
+            <a:r>
+              <a:rPr lang="en-US" sz="1800" b="1" dirty="0">
+                <a:solidFill>
+                  <a:srgbClr val="222831"/>
+                </a:solidFill>
+                <a:latin typeface="TH Sarabun New" pitchFamily="34" charset="0"/>
+                <a:ea typeface="TH Sarabun New" pitchFamily="34" charset="-122"/>
+                <a:cs typeface="TH Sarabun New" pitchFamily="34" charset="-120"/>
+              </a:rPr>
+              <a:t>เกณฑ์ผ่าน</a:t>
+            </a:r>
+            <a:endParaRPr lang="en-US" sz="1800" dirty="0"/>
+          </a:p>
+        </p:txBody>
+      </p:sp>
+      <p:sp>
+        <p:nvSpPr>
+          <p:cNvPr id="28" name="Text 26"/>
+          <p:cNvSpPr/>
+          <p:nvPr/>
+        </p:nvSpPr>
+        <p:spPr>
+          <a:xfrm>
+            <a:off x="6812280" y="3310128"/>
+            <a:ext cx="4480560" cy="1371600"/>
+          </a:xfrm>
+          <a:prstGeom prst="rect">
+            <a:avLst/>
+          </a:prstGeom>
+          <a:noFill/>
+          <a:ln/>
+        </p:spPr>
+        <p:txBody>
+          <a:bodyPr wrap="square" lIns="0" tIns="0" rIns="0" bIns="0" rtlCol="0" anchor="t"/>
+          <a:lstStyle/>
+          <a:p>
+            <a:pPr marL="342900" indent="-342900">
+              <a:spcAft>
+                <a:spcPts val="800"/>
+              </a:spcAft>
+              <a:buSzPct val="100000"/>
+              <a:buChar char="•"/>
+            </a:pPr>
+            <a:r>
+              <a:rPr lang="en-US" sz="1550" dirty="0">
+                <a:solidFill>
+                  <a:srgbClr val="393E46"/>
+                </a:solidFill>
+                <a:latin typeface="TH Sarabun New" pitchFamily="34" charset="0"/>
+                <a:ea typeface="TH Sarabun New" pitchFamily="34" charset="-122"/>
+                <a:cs typeface="TH Sarabun New" pitchFamily="34" charset="-120"/>
+              </a:rPr>
+              <a:t>ทุกคำสั่งขึ้นเลขเวอร์ชัน ไม่ขึ้น command not found</a:t>
+            </a:r>
+            <a:endParaRPr lang="en-US" sz="1550" dirty="0"/>
+          </a:p>
+          <a:p>
+            <a:pPr marL="342900" indent="-342900">
+              <a:spcAft>
+                <a:spcPts val="800"/>
+              </a:spcAft>
+              <a:buSzPct val="100000"/>
+              <a:buChar char="•"/>
+            </a:pPr>
+            <a:r>
+              <a:rPr lang="en-US" sz="1550" dirty="0">
+                <a:solidFill>
+                  <a:srgbClr val="393E46"/>
+                </a:solidFill>
+                <a:latin typeface="TH Sarabun New" pitchFamily="34" charset="0"/>
+                <a:ea typeface="TH Sarabun New" pitchFamily="34" charset="-122"/>
+                <a:cs typeface="TH Sarabun New" pitchFamily="34" charset="-120"/>
+              </a:rPr>
+              <a:t>เปิดโฟลเดอร์ fundinghub ใน Antigravity ได้</a:t>
+            </a:r>
+            <a:endParaRPr lang="en-US" sz="1550" dirty="0"/>
+          </a:p>
+          <a:p>
+            <a:pPr marL="342900" indent="-342900">
+              <a:spcAft>
+                <a:spcPts val="800"/>
+              </a:spcAft>
+              <a:buSzPct val="100000"/>
+              <a:buChar char="•"/>
+            </a:pPr>
+            <a:r>
+              <a:rPr lang="en-US" sz="1550" dirty="0">
+                <a:solidFill>
+                  <a:srgbClr val="393E46"/>
+                </a:solidFill>
+                <a:latin typeface="TH Sarabun New" pitchFamily="34" charset="0"/>
+                <a:ea typeface="TH Sarabun New" pitchFamily="34" charset="-122"/>
+                <a:cs typeface="TH Sarabun New" pitchFamily="34" charset="-120"/>
+              </a:rPr>
+              <a:t>มีไฟล์เปล่า SPEC_FundingHub.md รออยู่</a:t>
+            </a:r>
+            <a:endParaRPr lang="en-US" sz="1550" dirty="0"/>
+          </a:p>
+        </p:txBody>
+      </p:sp>
+      <p:sp>
+        <p:nvSpPr>
+          <p:cNvPr id="29" name="Text 27"/>
+          <p:cNvSpPr/>
+          <p:nvPr/>
+        </p:nvSpPr>
+        <p:spPr>
+          <a:xfrm>
+            <a:off x="594360" y="6263640"/>
+            <a:ext cx="10972800" cy="292608"/>
+          </a:xfrm>
+          <a:prstGeom prst="rect">
+            <a:avLst/>
+          </a:prstGeom>
+          <a:noFill/>
+          <a:ln/>
+        </p:spPr>
+        <p:txBody>
+          <a:bodyPr wrap="square" lIns="0" tIns="0" rIns="0" bIns="0" rtlCol="0" anchor="ctr"/>
+          <a:lstStyle/>
+          <a:p>
+            <a:pPr marL="0" indent="0">
+              <a:buNone/>
+            </a:pPr>
+            <a:r>
+              <a:rPr lang="en-US" sz="1300" dirty="0">
+                <a:solidFill>
+                  <a:srgbClr val="8A94A6"/>
+                </a:solidFill>
+                <a:latin typeface="TH Sarabun New" pitchFamily="34" charset="0"/>
+                <a:ea typeface="TH Sarabun New" pitchFamily="34" charset="-122"/>
+                <a:cs typeface="TH Sarabun New" pitchFamily="34" charset="-120"/>
+              </a:rPr>
+              <a:t>เอกสารแล็บ : LAB A  ·  การติดตั้งควรทำมาล่วงหน้าก่อนวันอบรม เวลาในห้องมีเพียง 10 นาทีสำหรับตรวจความพร้อม</a:t>
+            </a:r>
+            <a:endParaRPr lang="en-US" sz="1300" dirty="0"/>
+          </a:p>
+        </p:txBody>
+      </p:sp>
+    </p:spTree>
+  </p:cSld>
+  <p:clrMapOvr>
+    <a:masterClrMapping/>
+  </p:clrMapOvr>
+</p:sld>
+</file>
+
+<file path=ppt/slides/slide11.xml><?xml version="1.0" encoding="utf-8"?>
+<p:sld xmlns:a="http://schemas.openxmlformats.org/drawingml/2006/main" xmlns:r="http://schemas.openxmlformats.org/officeDocument/2006/relationships" xmlns:p="http://schemas.openxmlformats.org/presentationml/2006/main">
   <p:cSld name="Slide 11">
     <p:bg>
       <p:bgPr>
@@ -3516,7 +4690,7 @@
 </p:sld>
 </file>
 
-<file path=ppt/slides/slide11.xml><?xml version="1.0" encoding="utf-8"?>
+<file path=ppt/slides/slide12.xml><?xml version="1.0" encoding="utf-8"?>
 <p:sld xmlns:a="http://schemas.openxmlformats.org/drawingml/2006/main" xmlns:r="http://schemas.openxmlformats.org/officeDocument/2006/relationships" xmlns:p="http://schemas.openxmlformats.org/presentationml/2006/main">
   <p:cSld name="Slide 12">
     <p:bg>
@@ -3941,7 +5115,7 @@
 </p:sld>
 </file>
 
-<file path=ppt/slides/slide12.xml><?xml version="1.0" encoding="utf-8"?>
+<file path=ppt/slides/slide13.xml><?xml version="1.0" encoding="utf-8"?>
 <p:sld xmlns:a="http://schemas.openxmlformats.org/drawingml/2006/main" xmlns:r="http://schemas.openxmlformats.org/officeDocument/2006/relationships" xmlns:p="http://schemas.openxmlformats.org/presentationml/2006/main">
   <p:cSld name="Slide 13">
     <p:bg>
@@ -4890,7 +6064,7 @@
 </p:sld>
 </file>
 
-<file path=ppt/slides/slide13.xml><?xml version="1.0" encoding="utf-8"?>
+<file path=ppt/slides/slide14.xml><?xml version="1.0" encoding="utf-8"?>
 <p:sld xmlns:a="http://schemas.openxmlformats.org/drawingml/2006/main" xmlns:r="http://schemas.openxmlformats.org/officeDocument/2006/relationships" xmlns:p="http://schemas.openxmlformats.org/presentationml/2006/main">
   <p:cSld name="Slide 14">
     <p:bg>
@@ -5605,7 +6779,7 @@
 </p:sld>
 </file>
 
-<file path=ppt/slides/slide14.xml><?xml version="1.0" encoding="utf-8"?>
+<file path=ppt/slides/slide15.xml><?xml version="1.0" encoding="utf-8"?>
 <p:sld xmlns:a="http://schemas.openxmlformats.org/drawingml/2006/main" xmlns:r="http://schemas.openxmlformats.org/officeDocument/2006/relationships" xmlns:p="http://schemas.openxmlformats.org/presentationml/2006/main">
   <p:cSld name="Slide 16">
     <p:bg>
@@ -6667,7 +7841,7 @@
 </p:sld>
 </file>
 
-<file path=ppt/slides/slide15.xml><?xml version="1.0" encoding="utf-8"?>
+<file path=ppt/slides/slide16.xml><?xml version="1.0" encoding="utf-8"?>
 <p:sld xmlns:a="http://schemas.openxmlformats.org/drawingml/2006/main" xmlns:r="http://schemas.openxmlformats.org/officeDocument/2006/relationships" xmlns:p="http://schemas.openxmlformats.org/presentationml/2006/main">
   <p:cSld name="Slide 17">
     <p:bg>
@@ -6888,7 +8062,7 @@
 </p:sld>
 </file>
 
-<file path=ppt/slides/slide16.xml><?xml version="1.0" encoding="utf-8"?>
+<file path=ppt/slides/slide17.xml><?xml version="1.0" encoding="utf-8"?>
 <p:sld xmlns:a="http://schemas.openxmlformats.org/drawingml/2006/main" xmlns:r="http://schemas.openxmlformats.org/officeDocument/2006/relationships" xmlns:p="http://schemas.openxmlformats.org/presentationml/2006/main">
   <p:cSld name="Slide 18">
     <p:bg>
@@ -7864,7 +9038,7 @@
 </p:sld>
 </file>
 
-<file path=ppt/slides/slide17.xml><?xml version="1.0" encoding="utf-8"?>
+<file path=ppt/slides/slide18.xml><?xml version="1.0" encoding="utf-8"?>
 <p:sld xmlns:a="http://schemas.openxmlformats.org/drawingml/2006/main" xmlns:r="http://schemas.openxmlformats.org/officeDocument/2006/relationships" xmlns:p="http://schemas.openxmlformats.org/presentationml/2006/main">
   <p:cSld name="Slide 23">
     <p:bg>
@@ -8085,7 +9259,7 @@
 </p:sld>
 </file>
 
-<file path=ppt/slides/slide18.xml><?xml version="1.0" encoding="utf-8"?>
+<file path=ppt/slides/slide19.xml><?xml version="1.0" encoding="utf-8"?>
 <p:sld xmlns:a="http://schemas.openxmlformats.org/drawingml/2006/main" xmlns:r="http://schemas.openxmlformats.org/officeDocument/2006/relationships" xmlns:p="http://schemas.openxmlformats.org/presentationml/2006/main">
   <p:cSld name="Slide 24">
     <p:bg>
@@ -9177,7 +10351,110 @@
 </p:sld>
 </file>
 
-<file path=ppt/slides/slide19.xml><?xml version="1.0" encoding="utf-8"?>
+<file path=ppt/slides/slide2.xml><?xml version="1.0" encoding="utf-8"?>
+<p:sld xmlns:a="http://schemas.openxmlformats.org/drawingml/2006/main" xmlns:r="http://schemas.openxmlformats.org/officeDocument/2006/relationships" xmlns:p="http://schemas.openxmlformats.org/presentationml/2006/main">
+  <p:cSld>
+    <p:spTree>
+      <p:nvGrpSpPr>
+        <p:cNvPr id="1" name=""/>
+        <p:cNvGrpSpPr/>
+        <p:nvPr/>
+      </p:nvGrpSpPr>
+      <p:grpSpPr>
+        <a:xfrm>
+          <a:off x="0" y="0"/>
+          <a:ext cx="0" cy="0"/>
+          <a:chOff x="0" y="0"/>
+          <a:chExt cx="0" cy="0"/>
+        </a:xfrm>
+      </p:grpSpPr>
+      <p:pic>
+        <p:nvPicPr>
+          <p:cNvPr id="2" name="Picture 1">
+            <a:extLst>
+              <a:ext uri="{FF2B5EF4-FFF2-40B4-BE49-F238E27FC236}">
+                <a16:creationId xmlns:a16="http://schemas.microsoft.com/office/drawing/2014/main" id="{672B6859-8155-3FC0-4729-D2349EB114DD}"/>
+              </a:ext>
+            </a:extLst>
+          </p:cNvPr>
+          <p:cNvPicPr>
+            <a:picLocks noChangeAspect="1"/>
+          </p:cNvPicPr>
+          <p:nvPr/>
+        </p:nvPicPr>
+        <p:blipFill>
+          <a:blip r:embed="rId2"/>
+          <a:stretch>
+            <a:fillRect/>
+          </a:stretch>
+        </p:blipFill>
+        <p:spPr>
+          <a:xfrm>
+            <a:off x="1705449" y="1753538"/>
+            <a:ext cx="3621293" cy="3621293"/>
+          </a:xfrm>
+          <a:prstGeom prst="rect">
+            <a:avLst/>
+          </a:prstGeom>
+        </p:spPr>
+      </p:pic>
+      <p:sp>
+        <p:nvSpPr>
+          <p:cNvPr id="4" name="TextBox 3">
+            <a:extLst>
+              <a:ext uri="{FF2B5EF4-FFF2-40B4-BE49-F238E27FC236}">
+                <a16:creationId xmlns:a16="http://schemas.microsoft.com/office/drawing/2014/main" id="{266AA7FA-08A3-0813-318A-134AA6B5530F}"/>
+              </a:ext>
+            </a:extLst>
+          </p:cNvPr>
+          <p:cNvSpPr txBox="1"/>
+          <p:nvPr/>
+        </p:nvSpPr>
+        <p:spPr>
+          <a:xfrm>
+            <a:off x="6096000" y="3310268"/>
+            <a:ext cx="6096000" cy="523220"/>
+          </a:xfrm>
+          <a:prstGeom prst="rect">
+            <a:avLst/>
+          </a:prstGeom>
+          <a:noFill/>
+        </p:spPr>
+        <p:txBody>
+          <a:bodyPr wrap="square">
+            <a:spAutoFit/>
+          </a:bodyPr>
+          <a:lstStyle/>
+          <a:p>
+            <a:r>
+              <a:rPr lang="en-TH" sz="2800" b="0" i="0" u="none" strike="noStrike">
+                <a:solidFill>
+                  <a:schemeClr val="tx1"/>
+                </a:solidFill>
+                <a:effectLst/>
+                <a:latin typeface="+mn-lt"/>
+                <a:hlinkClick r:id="rId3"/>
+              </a:rPr>
+              <a:t>https://cmu.to/z84tQ</a:t>
+            </a:r>
+            <a:endParaRPr lang="en-TH" sz="2800"/>
+          </a:p>
+        </p:txBody>
+      </p:sp>
+    </p:spTree>
+    <p:extLst>
+      <p:ext uri="{BB962C8B-B14F-4D97-AF65-F5344CB8AC3E}">
+        <p14:creationId xmlns:p14="http://schemas.microsoft.com/office/powerpoint/2010/main" val="534680153"/>
+      </p:ext>
+    </p:extLst>
+  </p:cSld>
+  <p:clrMapOvr>
+    <a:masterClrMapping/>
+  </p:clrMapOvr>
+</p:sld>
+</file>
+
+<file path=ppt/slides/slide20.xml><?xml version="1.0" encoding="utf-8"?>
 <p:sld xmlns:a="http://schemas.openxmlformats.org/drawingml/2006/main" xmlns:r="http://schemas.openxmlformats.org/officeDocument/2006/relationships" xmlns:p="http://schemas.openxmlformats.org/presentationml/2006/main">
   <p:cSld name="Slide 25">
     <p:bg>
@@ -10450,917 +11727,7 @@
 </p:sld>
 </file>
 
-<file path=ppt/slides/slide2.xml><?xml version="1.0" encoding="utf-8"?>
-<p:sld xmlns:a="http://schemas.openxmlformats.org/drawingml/2006/main" xmlns:r="http://schemas.openxmlformats.org/officeDocument/2006/relationships" xmlns:p="http://schemas.openxmlformats.org/presentationml/2006/main">
-  <p:cSld name="Slide 2">
-    <p:bg>
-      <p:bgPr>
-        <a:solidFill>
-          <a:srgbClr val="FFFFFF"/>
-        </a:solidFill>
-        <a:effectLst/>
-      </p:bgPr>
-    </p:bg>
-    <p:spTree>
-      <p:nvGrpSpPr>
-        <p:cNvPr id="1" name=""/>
-        <p:cNvGrpSpPr/>
-        <p:nvPr/>
-      </p:nvGrpSpPr>
-      <p:grpSpPr>
-        <a:xfrm>
-          <a:off x="0" y="0"/>
-          <a:ext cx="0" cy="0"/>
-          <a:chOff x="0" y="0"/>
-          <a:chExt cx="0" cy="0"/>
-        </a:xfrm>
-      </p:grpSpPr>
-      <p:sp>
-        <p:nvSpPr>
-          <p:cNvPr id="2" name="Text 0"/>
-          <p:cNvSpPr/>
-          <p:nvPr/>
-        </p:nvSpPr>
-        <p:spPr>
-          <a:xfrm>
-            <a:off x="11018520" y="6263640"/>
-            <a:ext cx="548640" cy="274320"/>
-          </a:xfrm>
-          <a:prstGeom prst="rect">
-            <a:avLst/>
-          </a:prstGeom>
-          <a:noFill/>
-          <a:ln/>
-        </p:spPr>
-        <p:txBody>
-          <a:bodyPr wrap="square" lIns="0" tIns="0" rIns="0" bIns="0" rtlCol="0" anchor="ctr"/>
-          <a:lstStyle/>
-          <a:p>
-            <a:pPr marL="0" indent="0" algn="r">
-              <a:buNone/>
-            </a:pPr>
-            <a:r>
-              <a:rPr lang="en-US" sz="1200" dirty="0">
-                <a:solidFill>
-                  <a:srgbClr val="9AA3AD"/>
-                </a:solidFill>
-                <a:latin typeface="TH Sarabun New" pitchFamily="34" charset="0"/>
-                <a:ea typeface="TH Sarabun New" pitchFamily="34" charset="-122"/>
-                <a:cs typeface="TH Sarabun New" pitchFamily="34" charset="-120"/>
-              </a:rPr>
-              <a:t>2</a:t>
-            </a:r>
-            <a:endParaRPr lang="en-US" sz="1200" dirty="0"/>
-          </a:p>
-        </p:txBody>
-      </p:sp>
-      <p:sp>
-        <p:nvSpPr>
-          <p:cNvPr id="3" name="Text 1"/>
-          <p:cNvSpPr/>
-          <p:nvPr/>
-        </p:nvSpPr>
-        <p:spPr>
-          <a:xfrm>
-            <a:off x="594360" y="329184"/>
-            <a:ext cx="10972800" cy="566928"/>
-          </a:xfrm>
-          <a:prstGeom prst="rect">
-            <a:avLst/>
-          </a:prstGeom>
-          <a:noFill/>
-          <a:ln/>
-        </p:spPr>
-        <p:txBody>
-          <a:bodyPr wrap="square" lIns="0" tIns="0" rIns="0" bIns="0" rtlCol="0" anchor="ctr"/>
-          <a:lstStyle/>
-          <a:p>
-            <a:pPr marL="0" indent="0">
-              <a:buNone/>
-            </a:pPr>
-            <a:r>
-              <a:rPr lang="en-US" sz="3200" b="1" dirty="0">
-                <a:solidFill>
-                  <a:srgbClr val="222831"/>
-                </a:solidFill>
-                <a:latin typeface="TH Sarabun New" pitchFamily="34" charset="0"/>
-                <a:ea typeface="TH Sarabun New" pitchFamily="34" charset="-122"/>
-                <a:cs typeface="TH Sarabun New" pitchFamily="34" charset="-120"/>
-              </a:rPr>
-              <a:t>เป้าหมาย</a:t>
-            </a:r>
-            <a:endParaRPr lang="en-US" sz="3200" dirty="0"/>
-          </a:p>
-        </p:txBody>
-      </p:sp>
-      <p:sp>
-        <p:nvSpPr>
-          <p:cNvPr id="4" name="Text 2"/>
-          <p:cNvSpPr/>
-          <p:nvPr/>
-        </p:nvSpPr>
-        <p:spPr>
-          <a:xfrm>
-            <a:off x="594360" y="896112"/>
-            <a:ext cx="10972800" cy="329184"/>
-          </a:xfrm>
-          <a:prstGeom prst="rect">
-            <a:avLst/>
-          </a:prstGeom>
-          <a:noFill/>
-          <a:ln/>
-        </p:spPr>
-        <p:txBody>
-          <a:bodyPr wrap="square" lIns="0" tIns="0" rIns="0" bIns="0" rtlCol="0" anchor="ctr"/>
-          <a:lstStyle/>
-          <a:p>
-            <a:pPr marL="0" indent="0">
-              <a:buNone/>
-            </a:pPr>
-            <a:r>
-              <a:rPr lang="en-US" sz="1700" dirty="0">
-                <a:solidFill>
-                  <a:srgbClr val="8A94A6"/>
-                </a:solidFill>
-                <a:latin typeface="TH Sarabun New" pitchFamily="34" charset="0"/>
-                <a:ea typeface="TH Sarabun New" pitchFamily="34" charset="-122"/>
-                <a:cs typeface="TH Sarabun New" pitchFamily="34" charset="-120"/>
-              </a:rPr>
-              <a:t>เมื่อจบวันนี้ ผู้เข้าอบรมจะทำสิ่งเหล่านี้ได้ด้วยตนเอง</a:t>
-            </a:r>
-            <a:endParaRPr lang="en-US" sz="1700" dirty="0"/>
-          </a:p>
-        </p:txBody>
-      </p:sp>
-      <p:sp>
-        <p:nvSpPr>
-          <p:cNvPr id="5" name="Shape 3"/>
-          <p:cNvSpPr/>
-          <p:nvPr/>
-        </p:nvSpPr>
-        <p:spPr>
-          <a:xfrm>
-            <a:off x="594360" y="1481328"/>
-            <a:ext cx="5340096" cy="1371600"/>
-          </a:xfrm>
-          <a:prstGeom prst="roundRect">
-            <a:avLst>
-              <a:gd name="adj" fmla="val 6000"/>
-            </a:avLst>
-          </a:prstGeom>
-          <a:solidFill>
-            <a:srgbClr val="F5F7F8"/>
-          </a:solidFill>
-          <a:ln w="9525">
-            <a:solidFill>
-              <a:srgbClr val="F5F7F8"/>
-            </a:solidFill>
-            <a:prstDash val="solid"/>
-          </a:ln>
-          <a:effectLst>
-            <a:outerShdw blurRad="101600" dist="12700" dir="5400000" algn="bl" rotWithShape="0">
-              <a:srgbClr val="222831">
-                <a:alpha val="10000"/>
-              </a:srgbClr>
-            </a:outerShdw>
-          </a:effectLst>
-        </p:spPr>
-        <p:txBody>
-          <a:bodyPr/>
-          <a:lstStyle/>
-          <a:p>
-            <a:endParaRPr lang="en-TH"/>
-          </a:p>
-        </p:txBody>
-      </p:sp>
-      <p:sp>
-        <p:nvSpPr>
-          <p:cNvPr id="6" name="Shape 4"/>
-          <p:cNvSpPr/>
-          <p:nvPr/>
-        </p:nvSpPr>
-        <p:spPr>
-          <a:xfrm>
-            <a:off x="850392" y="1737360"/>
-            <a:ext cx="402336" cy="402336"/>
-          </a:xfrm>
-          <a:prstGeom prst="ellipse">
-            <a:avLst/>
-          </a:prstGeom>
-          <a:solidFill>
-            <a:srgbClr val="00ADB5"/>
-          </a:solidFill>
-          <a:ln w="12700">
-            <a:solidFill>
-              <a:srgbClr val="00ADB5"/>
-            </a:solidFill>
-            <a:prstDash val="solid"/>
-          </a:ln>
-        </p:spPr>
-        <p:txBody>
-          <a:bodyPr/>
-          <a:lstStyle/>
-          <a:p>
-            <a:endParaRPr lang="en-TH"/>
-          </a:p>
-        </p:txBody>
-      </p:sp>
-      <p:sp>
-        <p:nvSpPr>
-          <p:cNvPr id="7" name="Text 5"/>
-          <p:cNvSpPr/>
-          <p:nvPr/>
-        </p:nvSpPr>
-        <p:spPr>
-          <a:xfrm>
-            <a:off x="850392" y="1737360"/>
-            <a:ext cx="402336" cy="402336"/>
-          </a:xfrm>
-          <a:prstGeom prst="rect">
-            <a:avLst/>
-          </a:prstGeom>
-          <a:noFill/>
-          <a:ln/>
-        </p:spPr>
-        <p:txBody>
-          <a:bodyPr wrap="square" lIns="0" tIns="0" rIns="0" bIns="0" rtlCol="0" anchor="ctr"/>
-          <a:lstStyle/>
-          <a:p>
-            <a:pPr marL="0" indent="0" algn="ctr">
-              <a:buNone/>
-            </a:pPr>
-            <a:r>
-              <a:rPr lang="en-US" sz="1500" b="1" dirty="0">
-                <a:solidFill>
-                  <a:srgbClr val="FFFFFF"/>
-                </a:solidFill>
-                <a:latin typeface="TH Sarabun New" pitchFamily="34" charset="0"/>
-                <a:ea typeface="TH Sarabun New" pitchFamily="34" charset="-122"/>
-                <a:cs typeface="TH Sarabun New" pitchFamily="34" charset="-120"/>
-              </a:rPr>
-              <a:t>1</a:t>
-            </a:r>
-            <a:endParaRPr lang="en-US" sz="1500" dirty="0"/>
-          </a:p>
-        </p:txBody>
-      </p:sp>
-      <p:sp>
-        <p:nvSpPr>
-          <p:cNvPr id="8" name="Text 6"/>
-          <p:cNvSpPr/>
-          <p:nvPr/>
-        </p:nvSpPr>
-        <p:spPr>
-          <a:xfrm>
-            <a:off x="1380744" y="1700784"/>
-            <a:ext cx="4389120" cy="384048"/>
-          </a:xfrm>
-          <a:prstGeom prst="rect">
-            <a:avLst/>
-          </a:prstGeom>
-          <a:noFill/>
-          <a:ln/>
-        </p:spPr>
-        <p:txBody>
-          <a:bodyPr wrap="square" lIns="0" tIns="0" rIns="0" bIns="0" rtlCol="0" anchor="ctr"/>
-          <a:lstStyle/>
-          <a:p>
-            <a:pPr marL="0" indent="0">
-              <a:buNone/>
-            </a:pPr>
-            <a:r>
-              <a:rPr lang="en-US" sz="1900" b="1" dirty="0">
-                <a:solidFill>
-                  <a:srgbClr val="222831"/>
-                </a:solidFill>
-                <a:latin typeface="TH Sarabun New" pitchFamily="34" charset="0"/>
-                <a:ea typeface="TH Sarabun New" pitchFamily="34" charset="-122"/>
-                <a:cs typeface="TH Sarabun New" pitchFamily="34" charset="-120"/>
-              </a:rPr>
-              <a:t>เข้าใจโครงสร้างเว็บแอปพลิเคชัน</a:t>
-            </a:r>
-            <a:endParaRPr lang="en-US" sz="1900" dirty="0"/>
-          </a:p>
-        </p:txBody>
-      </p:sp>
-      <p:sp>
-        <p:nvSpPr>
-          <p:cNvPr id="9" name="Text 7"/>
-          <p:cNvSpPr/>
-          <p:nvPr/>
-        </p:nvSpPr>
-        <p:spPr>
-          <a:xfrm>
-            <a:off x="1380744" y="2121408"/>
-            <a:ext cx="4389120" cy="566928"/>
-          </a:xfrm>
-          <a:prstGeom prst="rect">
-            <a:avLst/>
-          </a:prstGeom>
-          <a:noFill/>
-          <a:ln/>
-        </p:spPr>
-        <p:txBody>
-          <a:bodyPr wrap="square" lIns="0" tIns="0" rIns="0" bIns="0" rtlCol="0" anchor="t"/>
-          <a:lstStyle/>
-          <a:p>
-            <a:pPr marL="0" indent="0">
-              <a:buNone/>
-            </a:pPr>
-            <a:r>
-              <a:rPr lang="en-US" sz="1550" dirty="0">
-                <a:solidFill>
-                  <a:srgbClr val="393E46"/>
-                </a:solidFill>
-                <a:latin typeface="TH Sarabun New" pitchFamily="34" charset="0"/>
-                <a:ea typeface="TH Sarabun New" pitchFamily="34" charset="-122"/>
-                <a:cs typeface="TH Sarabun New" pitchFamily="34" charset="-120"/>
-              </a:rPr>
-              <a:t>แยกออกว่า Frontend / Backend / Database ทำหน้าที่ต่างกันอย่างไร</a:t>
-            </a:r>
-            <a:endParaRPr lang="en-US" sz="1550" dirty="0"/>
-          </a:p>
-        </p:txBody>
-      </p:sp>
-      <p:sp>
-        <p:nvSpPr>
-          <p:cNvPr id="10" name="Shape 8"/>
-          <p:cNvSpPr/>
-          <p:nvPr/>
-        </p:nvSpPr>
-        <p:spPr>
-          <a:xfrm>
-            <a:off x="6227064" y="1481328"/>
-            <a:ext cx="5340096" cy="1371600"/>
-          </a:xfrm>
-          <a:prstGeom prst="roundRect">
-            <a:avLst>
-              <a:gd name="adj" fmla="val 6000"/>
-            </a:avLst>
-          </a:prstGeom>
-          <a:solidFill>
-            <a:srgbClr val="F5F7F8"/>
-          </a:solidFill>
-          <a:ln w="9525">
-            <a:solidFill>
-              <a:srgbClr val="F5F7F8"/>
-            </a:solidFill>
-            <a:prstDash val="solid"/>
-          </a:ln>
-          <a:effectLst>
-            <a:outerShdw blurRad="101600" dist="12700" dir="5400000" algn="bl" rotWithShape="0">
-              <a:srgbClr val="222831">
-                <a:alpha val="10000"/>
-              </a:srgbClr>
-            </a:outerShdw>
-          </a:effectLst>
-        </p:spPr>
-        <p:txBody>
-          <a:bodyPr/>
-          <a:lstStyle/>
-          <a:p>
-            <a:endParaRPr lang="en-TH"/>
-          </a:p>
-        </p:txBody>
-      </p:sp>
-      <p:sp>
-        <p:nvSpPr>
-          <p:cNvPr id="11" name="Shape 9"/>
-          <p:cNvSpPr/>
-          <p:nvPr/>
-        </p:nvSpPr>
-        <p:spPr>
-          <a:xfrm>
-            <a:off x="6483096" y="1737360"/>
-            <a:ext cx="402336" cy="402336"/>
-          </a:xfrm>
-          <a:prstGeom prst="ellipse">
-            <a:avLst/>
-          </a:prstGeom>
-          <a:solidFill>
-            <a:srgbClr val="00ADB5"/>
-          </a:solidFill>
-          <a:ln w="12700">
-            <a:solidFill>
-              <a:srgbClr val="00ADB5"/>
-            </a:solidFill>
-            <a:prstDash val="solid"/>
-          </a:ln>
-        </p:spPr>
-        <p:txBody>
-          <a:bodyPr/>
-          <a:lstStyle/>
-          <a:p>
-            <a:endParaRPr lang="en-TH"/>
-          </a:p>
-        </p:txBody>
-      </p:sp>
-      <p:sp>
-        <p:nvSpPr>
-          <p:cNvPr id="12" name="Text 10"/>
-          <p:cNvSpPr/>
-          <p:nvPr/>
-        </p:nvSpPr>
-        <p:spPr>
-          <a:xfrm>
-            <a:off x="6483096" y="1737360"/>
-            <a:ext cx="402336" cy="402336"/>
-          </a:xfrm>
-          <a:prstGeom prst="rect">
-            <a:avLst/>
-          </a:prstGeom>
-          <a:noFill/>
-          <a:ln/>
-        </p:spPr>
-        <p:txBody>
-          <a:bodyPr wrap="square" lIns="0" tIns="0" rIns="0" bIns="0" rtlCol="0" anchor="ctr"/>
-          <a:lstStyle/>
-          <a:p>
-            <a:pPr marL="0" indent="0" algn="ctr">
-              <a:buNone/>
-            </a:pPr>
-            <a:r>
-              <a:rPr lang="en-US" sz="1500" b="1" dirty="0">
-                <a:solidFill>
-                  <a:srgbClr val="FFFFFF"/>
-                </a:solidFill>
-                <a:latin typeface="TH Sarabun New" pitchFamily="34" charset="0"/>
-                <a:ea typeface="TH Sarabun New" pitchFamily="34" charset="-122"/>
-                <a:cs typeface="TH Sarabun New" pitchFamily="34" charset="-120"/>
-              </a:rPr>
-              <a:t>2</a:t>
-            </a:r>
-            <a:endParaRPr lang="en-US" sz="1500" dirty="0"/>
-          </a:p>
-        </p:txBody>
-      </p:sp>
-      <p:sp>
-        <p:nvSpPr>
-          <p:cNvPr id="13" name="Text 11"/>
-          <p:cNvSpPr/>
-          <p:nvPr/>
-        </p:nvSpPr>
-        <p:spPr>
-          <a:xfrm>
-            <a:off x="7013448" y="1700784"/>
-            <a:ext cx="4389120" cy="384048"/>
-          </a:xfrm>
-          <a:prstGeom prst="rect">
-            <a:avLst/>
-          </a:prstGeom>
-          <a:noFill/>
-          <a:ln/>
-        </p:spPr>
-        <p:txBody>
-          <a:bodyPr wrap="square" lIns="0" tIns="0" rIns="0" bIns="0" rtlCol="0" anchor="ctr"/>
-          <a:lstStyle/>
-          <a:p>
-            <a:pPr marL="0" indent="0">
-              <a:buNone/>
-            </a:pPr>
-            <a:r>
-              <a:rPr lang="en-US" sz="1900" b="1" dirty="0">
-                <a:solidFill>
-                  <a:srgbClr val="222831"/>
-                </a:solidFill>
-                <a:latin typeface="TH Sarabun New" pitchFamily="34" charset="0"/>
-                <a:ea typeface="TH Sarabun New" pitchFamily="34" charset="-122"/>
-                <a:cs typeface="TH Sarabun New" pitchFamily="34" charset="-120"/>
-              </a:rPr>
-              <a:t>สั่งงาน AI Agent ด้วย Antigravity</a:t>
-            </a:r>
-            <a:endParaRPr lang="en-US" sz="1900" dirty="0"/>
-          </a:p>
-        </p:txBody>
-      </p:sp>
-      <p:sp>
-        <p:nvSpPr>
-          <p:cNvPr id="14" name="Text 12"/>
-          <p:cNvSpPr/>
-          <p:nvPr/>
-        </p:nvSpPr>
-        <p:spPr>
-          <a:xfrm>
-            <a:off x="7013448" y="2121408"/>
-            <a:ext cx="4389120" cy="566928"/>
-          </a:xfrm>
-          <a:prstGeom prst="rect">
-            <a:avLst/>
-          </a:prstGeom>
-          <a:noFill/>
-          <a:ln/>
-        </p:spPr>
-        <p:txBody>
-          <a:bodyPr wrap="square" lIns="0" tIns="0" rIns="0" bIns="0" rtlCol="0" anchor="t"/>
-          <a:lstStyle/>
-          <a:p>
-            <a:pPr marL="0" indent="0">
-              <a:buNone/>
-            </a:pPr>
-            <a:r>
-              <a:rPr lang="en-US" sz="1550" dirty="0">
-                <a:solidFill>
-                  <a:srgbClr val="393E46"/>
-                </a:solidFill>
-                <a:latin typeface="TH Sarabun New" pitchFamily="34" charset="0"/>
-                <a:ea typeface="TH Sarabun New" pitchFamily="34" charset="-122"/>
-                <a:cs typeface="TH Sarabun New" pitchFamily="34" charset="-120"/>
-              </a:rPr>
-              <a:t>รู้จัก Editor, Agent, Artifacts และ Browser Subagent</a:t>
-            </a:r>
-            <a:endParaRPr lang="en-US" sz="1550" dirty="0"/>
-          </a:p>
-        </p:txBody>
-      </p:sp>
-      <p:sp>
-        <p:nvSpPr>
-          <p:cNvPr id="15" name="Shape 13"/>
-          <p:cNvSpPr/>
-          <p:nvPr/>
-        </p:nvSpPr>
-        <p:spPr>
-          <a:xfrm>
-            <a:off x="594360" y="3054096"/>
-            <a:ext cx="5340096" cy="1371600"/>
-          </a:xfrm>
-          <a:prstGeom prst="roundRect">
-            <a:avLst>
-              <a:gd name="adj" fmla="val 6000"/>
-            </a:avLst>
-          </a:prstGeom>
-          <a:solidFill>
-            <a:srgbClr val="F5F7F8"/>
-          </a:solidFill>
-          <a:ln w="9525">
-            <a:solidFill>
-              <a:srgbClr val="F5F7F8"/>
-            </a:solidFill>
-            <a:prstDash val="solid"/>
-          </a:ln>
-          <a:effectLst>
-            <a:outerShdw blurRad="101600" dist="12700" dir="5400000" algn="bl" rotWithShape="0">
-              <a:srgbClr val="222831">
-                <a:alpha val="10000"/>
-              </a:srgbClr>
-            </a:outerShdw>
-          </a:effectLst>
-        </p:spPr>
-        <p:txBody>
-          <a:bodyPr/>
-          <a:lstStyle/>
-          <a:p>
-            <a:endParaRPr lang="en-TH"/>
-          </a:p>
-        </p:txBody>
-      </p:sp>
-      <p:sp>
-        <p:nvSpPr>
-          <p:cNvPr id="16" name="Shape 14"/>
-          <p:cNvSpPr/>
-          <p:nvPr/>
-        </p:nvSpPr>
-        <p:spPr>
-          <a:xfrm>
-            <a:off x="850392" y="3310128"/>
-            <a:ext cx="402336" cy="402336"/>
-          </a:xfrm>
-          <a:prstGeom prst="ellipse">
-            <a:avLst/>
-          </a:prstGeom>
-          <a:solidFill>
-            <a:srgbClr val="00ADB5"/>
-          </a:solidFill>
-          <a:ln w="12700">
-            <a:solidFill>
-              <a:srgbClr val="00ADB5"/>
-            </a:solidFill>
-            <a:prstDash val="solid"/>
-          </a:ln>
-        </p:spPr>
-        <p:txBody>
-          <a:bodyPr/>
-          <a:lstStyle/>
-          <a:p>
-            <a:endParaRPr lang="en-TH"/>
-          </a:p>
-        </p:txBody>
-      </p:sp>
-      <p:sp>
-        <p:nvSpPr>
-          <p:cNvPr id="17" name="Text 15"/>
-          <p:cNvSpPr/>
-          <p:nvPr/>
-        </p:nvSpPr>
-        <p:spPr>
-          <a:xfrm>
-            <a:off x="850392" y="3310128"/>
-            <a:ext cx="402336" cy="402336"/>
-          </a:xfrm>
-          <a:prstGeom prst="rect">
-            <a:avLst/>
-          </a:prstGeom>
-          <a:noFill/>
-          <a:ln/>
-        </p:spPr>
-        <p:txBody>
-          <a:bodyPr wrap="square" lIns="0" tIns="0" rIns="0" bIns="0" rtlCol="0" anchor="ctr"/>
-          <a:lstStyle/>
-          <a:p>
-            <a:pPr marL="0" indent="0" algn="ctr">
-              <a:buNone/>
-            </a:pPr>
-            <a:r>
-              <a:rPr lang="en-US" sz="1500" b="1" dirty="0">
-                <a:solidFill>
-                  <a:srgbClr val="FFFFFF"/>
-                </a:solidFill>
-                <a:latin typeface="TH Sarabun New" pitchFamily="34" charset="0"/>
-                <a:ea typeface="TH Sarabun New" pitchFamily="34" charset="-122"/>
-                <a:cs typeface="TH Sarabun New" pitchFamily="34" charset="-120"/>
-              </a:rPr>
-              <a:t>3</a:t>
-            </a:r>
-            <a:endParaRPr lang="en-US" sz="1500" dirty="0"/>
-          </a:p>
-        </p:txBody>
-      </p:sp>
-      <p:sp>
-        <p:nvSpPr>
-          <p:cNvPr id="18" name="Text 16"/>
-          <p:cNvSpPr/>
-          <p:nvPr/>
-        </p:nvSpPr>
-        <p:spPr>
-          <a:xfrm>
-            <a:off x="1380744" y="3273552"/>
-            <a:ext cx="4389120" cy="384048"/>
-          </a:xfrm>
-          <a:prstGeom prst="rect">
-            <a:avLst/>
-          </a:prstGeom>
-          <a:noFill/>
-          <a:ln/>
-        </p:spPr>
-        <p:txBody>
-          <a:bodyPr wrap="square" lIns="0" tIns="0" rIns="0" bIns="0" rtlCol="0" anchor="ctr"/>
-          <a:lstStyle/>
-          <a:p>
-            <a:pPr marL="0" indent="0">
-              <a:buNone/>
-            </a:pPr>
-            <a:r>
-              <a:rPr lang="en-US" sz="1900" b="1" dirty="0">
-                <a:solidFill>
-                  <a:srgbClr val="222831"/>
-                </a:solidFill>
-                <a:latin typeface="TH Sarabun New" pitchFamily="34" charset="0"/>
-                <a:ea typeface="TH Sarabun New" pitchFamily="34" charset="-122"/>
-                <a:cs typeface="TH Sarabun New" pitchFamily="34" charset="-120"/>
-              </a:rPr>
-              <a:t>เขียนสเปกที่ AI ทำตามได้จริง</a:t>
-            </a:r>
-            <a:endParaRPr lang="en-US" sz="1900" dirty="0"/>
-          </a:p>
-        </p:txBody>
-      </p:sp>
-      <p:sp>
-        <p:nvSpPr>
-          <p:cNvPr id="19" name="Text 17"/>
-          <p:cNvSpPr/>
-          <p:nvPr/>
-        </p:nvSpPr>
-        <p:spPr>
-          <a:xfrm>
-            <a:off x="1380744" y="3694176"/>
-            <a:ext cx="4389120" cy="566928"/>
-          </a:xfrm>
-          <a:prstGeom prst="rect">
-            <a:avLst/>
-          </a:prstGeom>
-          <a:noFill/>
-          <a:ln/>
-        </p:spPr>
-        <p:txBody>
-          <a:bodyPr wrap="square" lIns="0" tIns="0" rIns="0" bIns="0" rtlCol="0" anchor="t"/>
-          <a:lstStyle/>
-          <a:p>
-            <a:pPr marL="0" indent="0">
-              <a:buNone/>
-            </a:pPr>
-            <a:r>
-              <a:rPr lang="en-US" sz="1550" dirty="0">
-                <a:solidFill>
-                  <a:srgbClr val="393E46"/>
-                </a:solidFill>
-                <a:latin typeface="TH Sarabun New" pitchFamily="34" charset="0"/>
-                <a:ea typeface="TH Sarabun New" pitchFamily="34" charset="-122"/>
-                <a:cs typeface="TH Sarabun New" pitchFamily="34" charset="-120"/>
-              </a:rPr>
-              <a:t>แปลงโจทย์เป็นเอกสารสเปกไฟล์เดียว พร้อมเกณฑ์ยอมรับที่วัดผลได้</a:t>
-            </a:r>
-            <a:endParaRPr lang="en-US" sz="1550" dirty="0"/>
-          </a:p>
-        </p:txBody>
-      </p:sp>
-      <p:sp>
-        <p:nvSpPr>
-          <p:cNvPr id="20" name="Shape 18"/>
-          <p:cNvSpPr/>
-          <p:nvPr/>
-        </p:nvSpPr>
-        <p:spPr>
-          <a:xfrm>
-            <a:off x="6227064" y="3054096"/>
-            <a:ext cx="5340096" cy="1371600"/>
-          </a:xfrm>
-          <a:prstGeom prst="roundRect">
-            <a:avLst>
-              <a:gd name="adj" fmla="val 6000"/>
-            </a:avLst>
-          </a:prstGeom>
-          <a:solidFill>
-            <a:srgbClr val="F5F7F8"/>
-          </a:solidFill>
-          <a:ln w="9525">
-            <a:solidFill>
-              <a:srgbClr val="F5F7F8"/>
-            </a:solidFill>
-            <a:prstDash val="solid"/>
-          </a:ln>
-          <a:effectLst>
-            <a:outerShdw blurRad="101600" dist="12700" dir="5400000" algn="bl" rotWithShape="0">
-              <a:srgbClr val="222831">
-                <a:alpha val="10000"/>
-              </a:srgbClr>
-            </a:outerShdw>
-          </a:effectLst>
-        </p:spPr>
-        <p:txBody>
-          <a:bodyPr/>
-          <a:lstStyle/>
-          <a:p>
-            <a:endParaRPr lang="en-TH"/>
-          </a:p>
-        </p:txBody>
-      </p:sp>
-      <p:sp>
-        <p:nvSpPr>
-          <p:cNvPr id="21" name="Shape 19"/>
-          <p:cNvSpPr/>
-          <p:nvPr/>
-        </p:nvSpPr>
-        <p:spPr>
-          <a:xfrm>
-            <a:off x="6483096" y="3310128"/>
-            <a:ext cx="402336" cy="402336"/>
-          </a:xfrm>
-          <a:prstGeom prst="ellipse">
-            <a:avLst/>
-          </a:prstGeom>
-          <a:solidFill>
-            <a:srgbClr val="00ADB5"/>
-          </a:solidFill>
-          <a:ln w="12700">
-            <a:solidFill>
-              <a:srgbClr val="00ADB5"/>
-            </a:solidFill>
-            <a:prstDash val="solid"/>
-          </a:ln>
-        </p:spPr>
-        <p:txBody>
-          <a:bodyPr/>
-          <a:lstStyle/>
-          <a:p>
-            <a:endParaRPr lang="en-TH"/>
-          </a:p>
-        </p:txBody>
-      </p:sp>
-      <p:sp>
-        <p:nvSpPr>
-          <p:cNvPr id="22" name="Text 20"/>
-          <p:cNvSpPr/>
-          <p:nvPr/>
-        </p:nvSpPr>
-        <p:spPr>
-          <a:xfrm>
-            <a:off x="6483096" y="3310128"/>
-            <a:ext cx="402336" cy="402336"/>
-          </a:xfrm>
-          <a:prstGeom prst="rect">
-            <a:avLst/>
-          </a:prstGeom>
-          <a:noFill/>
-          <a:ln/>
-        </p:spPr>
-        <p:txBody>
-          <a:bodyPr wrap="square" lIns="0" tIns="0" rIns="0" bIns="0" rtlCol="0" anchor="ctr"/>
-          <a:lstStyle/>
-          <a:p>
-            <a:pPr marL="0" indent="0" algn="ctr">
-              <a:buNone/>
-            </a:pPr>
-            <a:r>
-              <a:rPr lang="en-US" sz="1500" b="1" dirty="0">
-                <a:solidFill>
-                  <a:srgbClr val="FFFFFF"/>
-                </a:solidFill>
-                <a:latin typeface="TH Sarabun New" pitchFamily="34" charset="0"/>
-                <a:ea typeface="TH Sarabun New" pitchFamily="34" charset="-122"/>
-                <a:cs typeface="TH Sarabun New" pitchFamily="34" charset="-120"/>
-              </a:rPr>
-              <a:t>4</a:t>
-            </a:r>
-            <a:endParaRPr lang="en-US" sz="1500" dirty="0"/>
-          </a:p>
-        </p:txBody>
-      </p:sp>
-      <p:sp>
-        <p:nvSpPr>
-          <p:cNvPr id="23" name="Text 21"/>
-          <p:cNvSpPr/>
-          <p:nvPr/>
-        </p:nvSpPr>
-        <p:spPr>
-          <a:xfrm>
-            <a:off x="7013448" y="3273552"/>
-            <a:ext cx="4389120" cy="384048"/>
-          </a:xfrm>
-          <a:prstGeom prst="rect">
-            <a:avLst/>
-          </a:prstGeom>
-          <a:noFill/>
-          <a:ln/>
-        </p:spPr>
-        <p:txBody>
-          <a:bodyPr wrap="square" lIns="0" tIns="0" rIns="0" bIns="0" rtlCol="0" anchor="ctr"/>
-          <a:lstStyle/>
-          <a:p>
-            <a:pPr marL="0" indent="0">
-              <a:buNone/>
-            </a:pPr>
-            <a:r>
-              <a:rPr lang="en-US" sz="1900" b="1" dirty="0">
-                <a:solidFill>
-                  <a:srgbClr val="222831"/>
-                </a:solidFill>
-                <a:latin typeface="TH Sarabun New" pitchFamily="34" charset="0"/>
-                <a:ea typeface="TH Sarabun New" pitchFamily="34" charset="-122"/>
-                <a:cs typeface="TH Sarabun New" pitchFamily="34" charset="-120"/>
-              </a:rPr>
-              <a:t>สร้างเว็บที่ใช้งานได้จริงและนำขึ้นระบบ</a:t>
-            </a:r>
-            <a:endParaRPr lang="en-US" sz="1900" dirty="0"/>
-          </a:p>
-        </p:txBody>
-      </p:sp>
-      <p:sp>
-        <p:nvSpPr>
-          <p:cNvPr id="24" name="Text 22"/>
-          <p:cNvSpPr/>
-          <p:nvPr/>
-        </p:nvSpPr>
-        <p:spPr>
-          <a:xfrm>
-            <a:off x="7013448" y="3694176"/>
-            <a:ext cx="4389120" cy="566928"/>
-          </a:xfrm>
-          <a:prstGeom prst="rect">
-            <a:avLst/>
-          </a:prstGeom>
-          <a:noFill/>
-          <a:ln/>
-        </p:spPr>
-        <p:txBody>
-          <a:bodyPr wrap="square" lIns="0" tIns="0" rIns="0" bIns="0" rtlCol="0" anchor="t"/>
-          <a:lstStyle/>
-          <a:p>
-            <a:pPr marL="0" indent="0">
-              <a:buNone/>
-            </a:pPr>
-            <a:r>
-              <a:rPr lang="en-US" sz="1550" dirty="0">
-                <a:solidFill>
-                  <a:srgbClr val="393E46"/>
-                </a:solidFill>
-                <a:latin typeface="TH Sarabun New" pitchFamily="34" charset="0"/>
-                <a:ea typeface="TH Sarabun New" pitchFamily="34" charset="-122"/>
-                <a:cs typeface="TH Sarabun New" pitchFamily="34" charset="-120"/>
-              </a:rPr>
-              <a:t>ครบ 4 หน้า เชื่อมฐานข้อมูลจริง และเปิดจาก URL สาธารณะ</a:t>
-            </a:r>
-            <a:endParaRPr lang="en-US" sz="1550" dirty="0"/>
-          </a:p>
-        </p:txBody>
-      </p:sp>
-    </p:spTree>
-  </p:cSld>
-  <p:clrMapOvr>
-    <a:masterClrMapping/>
-  </p:clrMapOvr>
-</p:sld>
-</file>
-
-<file path=ppt/slides/slide20.xml><?xml version="1.0" encoding="utf-8"?>
+<file path=ppt/slides/slide21.xml><?xml version="1.0" encoding="utf-8"?>
 <p:sld xmlns:a="http://schemas.openxmlformats.org/drawingml/2006/main" xmlns:r="http://schemas.openxmlformats.org/officeDocument/2006/relationships" xmlns:p="http://schemas.openxmlformats.org/presentationml/2006/main">
   <p:cSld>
     <p:spTree>
@@ -11520,7 +11887,7 @@
 </p:sld>
 </file>
 
-<file path=ppt/slides/slide21.xml><?xml version="1.0" encoding="utf-8"?>
+<file path=ppt/slides/slide22.xml><?xml version="1.0" encoding="utf-8"?>
 <p:sld xmlns:a="http://schemas.openxmlformats.org/drawingml/2006/main" xmlns:r="http://schemas.openxmlformats.org/officeDocument/2006/relationships" xmlns:p="http://schemas.openxmlformats.org/presentationml/2006/main">
   <p:cSld name="Slide 26">
     <p:bg>
@@ -12988,7 +13355,7 @@
 </p:sld>
 </file>
 
-<file path=ppt/slides/slide22.xml><?xml version="1.0" encoding="utf-8"?>
+<file path=ppt/slides/slide23.xml><?xml version="1.0" encoding="utf-8"?>
 <p:sld xmlns:a="http://schemas.openxmlformats.org/drawingml/2006/main" xmlns:r="http://schemas.openxmlformats.org/officeDocument/2006/relationships" xmlns:p="http://schemas.openxmlformats.org/presentationml/2006/main">
   <p:cSld>
     <p:spTree>
@@ -13083,7 +13450,7 @@
 </p:sld>
 </file>
 
-<file path=ppt/slides/slide23.xml><?xml version="1.0" encoding="utf-8"?>
+<file path=ppt/slides/slide24.xml><?xml version="1.0" encoding="utf-8"?>
 <p:sld xmlns:a="http://schemas.openxmlformats.org/drawingml/2006/main" xmlns:r="http://schemas.openxmlformats.org/officeDocument/2006/relationships" xmlns:p="http://schemas.openxmlformats.org/presentationml/2006/main">
   <p:cSld name="Slide 27">
     <p:bg>
@@ -14472,7 +14839,7 @@
 </p:sld>
 </file>
 
-<file path=ppt/slides/slide24.xml><?xml version="1.0" encoding="utf-8"?>
+<file path=ppt/slides/slide25.xml><?xml version="1.0" encoding="utf-8"?>
 <p:sld xmlns:a="http://schemas.openxmlformats.org/drawingml/2006/main" xmlns:r="http://schemas.openxmlformats.org/officeDocument/2006/relationships" xmlns:p="http://schemas.openxmlformats.org/presentationml/2006/main">
   <p:cSld>
     <p:spTree>
@@ -14567,7 +14934,7 @@
 </p:sld>
 </file>
 
-<file path=ppt/slides/slide25.xml><?xml version="1.0" encoding="utf-8"?>
+<file path=ppt/slides/slide26.xml><?xml version="1.0" encoding="utf-8"?>
 <p:sld xmlns:a="http://schemas.openxmlformats.org/drawingml/2006/main" xmlns:r="http://schemas.openxmlformats.org/officeDocument/2006/relationships" xmlns:p="http://schemas.openxmlformats.org/presentationml/2006/main">
   <p:cSld name="Slide 29">
     <p:bg>
@@ -14788,7 +15155,7 @@
 </p:sld>
 </file>
 
-<file path=ppt/slides/slide26.xml><?xml version="1.0" encoding="utf-8"?>
+<file path=ppt/slides/slide27.xml><?xml version="1.0" encoding="utf-8"?>
 <p:sld xmlns:a="http://schemas.openxmlformats.org/drawingml/2006/main" xmlns:r="http://schemas.openxmlformats.org/officeDocument/2006/relationships" xmlns:p="http://schemas.openxmlformats.org/presentationml/2006/main">
   <p:cSld name="Slide 30">
     <p:bg>
@@ -15920,7 +16287,7 @@
 </p:sld>
 </file>
 
-<file path=ppt/slides/slide27.xml><?xml version="1.0" encoding="utf-8"?>
+<file path=ppt/slides/slide28.xml><?xml version="1.0" encoding="utf-8"?>
 <p:sld xmlns:a="http://schemas.openxmlformats.org/drawingml/2006/main" xmlns:r="http://schemas.openxmlformats.org/officeDocument/2006/relationships" xmlns:p="http://schemas.openxmlformats.org/presentationml/2006/main">
   <p:cSld>
     <p:spTree>
@@ -15992,7 +16359,7 @@
 </p:sld>
 </file>
 
-<file path=ppt/slides/slide28.xml><?xml version="1.0" encoding="utf-8"?>
+<file path=ppt/slides/slide29.xml><?xml version="1.0" encoding="utf-8"?>
 <p:sld xmlns:a="http://schemas.openxmlformats.org/drawingml/2006/main" xmlns:r="http://schemas.openxmlformats.org/officeDocument/2006/relationships" xmlns:p="http://schemas.openxmlformats.org/presentationml/2006/main">
   <p:cSld name="Slide 37">
     <p:bg>
@@ -16902,7 +17269,917 @@
 </p:sld>
 </file>
 
-<file path=ppt/slides/slide29.xml><?xml version="1.0" encoding="utf-8"?>
+<file path=ppt/slides/slide3.xml><?xml version="1.0" encoding="utf-8"?>
+<p:sld xmlns:a="http://schemas.openxmlformats.org/drawingml/2006/main" xmlns:r="http://schemas.openxmlformats.org/officeDocument/2006/relationships" xmlns:p="http://schemas.openxmlformats.org/presentationml/2006/main">
+  <p:cSld name="Slide 2">
+    <p:bg>
+      <p:bgPr>
+        <a:solidFill>
+          <a:srgbClr val="FFFFFF"/>
+        </a:solidFill>
+        <a:effectLst/>
+      </p:bgPr>
+    </p:bg>
+    <p:spTree>
+      <p:nvGrpSpPr>
+        <p:cNvPr id="1" name=""/>
+        <p:cNvGrpSpPr/>
+        <p:nvPr/>
+      </p:nvGrpSpPr>
+      <p:grpSpPr>
+        <a:xfrm>
+          <a:off x="0" y="0"/>
+          <a:ext cx="0" cy="0"/>
+          <a:chOff x="0" y="0"/>
+          <a:chExt cx="0" cy="0"/>
+        </a:xfrm>
+      </p:grpSpPr>
+      <p:sp>
+        <p:nvSpPr>
+          <p:cNvPr id="2" name="Text 0"/>
+          <p:cNvSpPr/>
+          <p:nvPr/>
+        </p:nvSpPr>
+        <p:spPr>
+          <a:xfrm>
+            <a:off x="11018520" y="6263640"/>
+            <a:ext cx="548640" cy="274320"/>
+          </a:xfrm>
+          <a:prstGeom prst="rect">
+            <a:avLst/>
+          </a:prstGeom>
+          <a:noFill/>
+          <a:ln/>
+        </p:spPr>
+        <p:txBody>
+          <a:bodyPr wrap="square" lIns="0" tIns="0" rIns="0" bIns="0" rtlCol="0" anchor="ctr"/>
+          <a:lstStyle/>
+          <a:p>
+            <a:pPr marL="0" indent="0" algn="r">
+              <a:buNone/>
+            </a:pPr>
+            <a:r>
+              <a:rPr lang="en-US" sz="1200" dirty="0">
+                <a:solidFill>
+                  <a:srgbClr val="9AA3AD"/>
+                </a:solidFill>
+                <a:latin typeface="TH Sarabun New" pitchFamily="34" charset="0"/>
+                <a:ea typeface="TH Sarabun New" pitchFamily="34" charset="-122"/>
+                <a:cs typeface="TH Sarabun New" pitchFamily="34" charset="-120"/>
+              </a:rPr>
+              <a:t>2</a:t>
+            </a:r>
+            <a:endParaRPr lang="en-US" sz="1200" dirty="0"/>
+          </a:p>
+        </p:txBody>
+      </p:sp>
+      <p:sp>
+        <p:nvSpPr>
+          <p:cNvPr id="3" name="Text 1"/>
+          <p:cNvSpPr/>
+          <p:nvPr/>
+        </p:nvSpPr>
+        <p:spPr>
+          <a:xfrm>
+            <a:off x="594360" y="329184"/>
+            <a:ext cx="10972800" cy="566928"/>
+          </a:xfrm>
+          <a:prstGeom prst="rect">
+            <a:avLst/>
+          </a:prstGeom>
+          <a:noFill/>
+          <a:ln/>
+        </p:spPr>
+        <p:txBody>
+          <a:bodyPr wrap="square" lIns="0" tIns="0" rIns="0" bIns="0" rtlCol="0" anchor="ctr"/>
+          <a:lstStyle/>
+          <a:p>
+            <a:pPr marL="0" indent="0">
+              <a:buNone/>
+            </a:pPr>
+            <a:r>
+              <a:rPr lang="en-US" sz="3200" b="1" dirty="0">
+                <a:solidFill>
+                  <a:srgbClr val="222831"/>
+                </a:solidFill>
+                <a:latin typeface="TH Sarabun New" pitchFamily="34" charset="0"/>
+                <a:ea typeface="TH Sarabun New" pitchFamily="34" charset="-122"/>
+                <a:cs typeface="TH Sarabun New" pitchFamily="34" charset="-120"/>
+              </a:rPr>
+              <a:t>เป้าหมาย</a:t>
+            </a:r>
+            <a:endParaRPr lang="en-US" sz="3200" dirty="0"/>
+          </a:p>
+        </p:txBody>
+      </p:sp>
+      <p:sp>
+        <p:nvSpPr>
+          <p:cNvPr id="4" name="Text 2"/>
+          <p:cNvSpPr/>
+          <p:nvPr/>
+        </p:nvSpPr>
+        <p:spPr>
+          <a:xfrm>
+            <a:off x="594360" y="896112"/>
+            <a:ext cx="10972800" cy="329184"/>
+          </a:xfrm>
+          <a:prstGeom prst="rect">
+            <a:avLst/>
+          </a:prstGeom>
+          <a:noFill/>
+          <a:ln/>
+        </p:spPr>
+        <p:txBody>
+          <a:bodyPr wrap="square" lIns="0" tIns="0" rIns="0" bIns="0" rtlCol="0" anchor="ctr"/>
+          <a:lstStyle/>
+          <a:p>
+            <a:pPr marL="0" indent="0">
+              <a:buNone/>
+            </a:pPr>
+            <a:r>
+              <a:rPr lang="en-US" sz="1700" dirty="0">
+                <a:solidFill>
+                  <a:srgbClr val="8A94A6"/>
+                </a:solidFill>
+                <a:latin typeface="TH Sarabun New" pitchFamily="34" charset="0"/>
+                <a:ea typeface="TH Sarabun New" pitchFamily="34" charset="-122"/>
+                <a:cs typeface="TH Sarabun New" pitchFamily="34" charset="-120"/>
+              </a:rPr>
+              <a:t>เมื่อจบวันนี้ ผู้เข้าอบรมจะทำสิ่งเหล่านี้ได้ด้วยตนเอง</a:t>
+            </a:r>
+            <a:endParaRPr lang="en-US" sz="1700" dirty="0"/>
+          </a:p>
+        </p:txBody>
+      </p:sp>
+      <p:sp>
+        <p:nvSpPr>
+          <p:cNvPr id="5" name="Shape 3"/>
+          <p:cNvSpPr/>
+          <p:nvPr/>
+        </p:nvSpPr>
+        <p:spPr>
+          <a:xfrm>
+            <a:off x="594360" y="1481328"/>
+            <a:ext cx="5340096" cy="1371600"/>
+          </a:xfrm>
+          <a:prstGeom prst="roundRect">
+            <a:avLst>
+              <a:gd name="adj" fmla="val 6000"/>
+            </a:avLst>
+          </a:prstGeom>
+          <a:solidFill>
+            <a:srgbClr val="F5F7F8"/>
+          </a:solidFill>
+          <a:ln w="9525">
+            <a:solidFill>
+              <a:srgbClr val="F5F7F8"/>
+            </a:solidFill>
+            <a:prstDash val="solid"/>
+          </a:ln>
+          <a:effectLst>
+            <a:outerShdw blurRad="101600" dist="12700" dir="5400000" algn="bl" rotWithShape="0">
+              <a:srgbClr val="222831">
+                <a:alpha val="10000"/>
+              </a:srgbClr>
+            </a:outerShdw>
+          </a:effectLst>
+        </p:spPr>
+        <p:txBody>
+          <a:bodyPr/>
+          <a:lstStyle/>
+          <a:p>
+            <a:endParaRPr lang="en-TH"/>
+          </a:p>
+        </p:txBody>
+      </p:sp>
+      <p:sp>
+        <p:nvSpPr>
+          <p:cNvPr id="6" name="Shape 4"/>
+          <p:cNvSpPr/>
+          <p:nvPr/>
+        </p:nvSpPr>
+        <p:spPr>
+          <a:xfrm>
+            <a:off x="850392" y="1737360"/>
+            <a:ext cx="402336" cy="402336"/>
+          </a:xfrm>
+          <a:prstGeom prst="ellipse">
+            <a:avLst/>
+          </a:prstGeom>
+          <a:solidFill>
+            <a:srgbClr val="00ADB5"/>
+          </a:solidFill>
+          <a:ln w="12700">
+            <a:solidFill>
+              <a:srgbClr val="00ADB5"/>
+            </a:solidFill>
+            <a:prstDash val="solid"/>
+          </a:ln>
+        </p:spPr>
+        <p:txBody>
+          <a:bodyPr/>
+          <a:lstStyle/>
+          <a:p>
+            <a:endParaRPr lang="en-TH"/>
+          </a:p>
+        </p:txBody>
+      </p:sp>
+      <p:sp>
+        <p:nvSpPr>
+          <p:cNvPr id="7" name="Text 5"/>
+          <p:cNvSpPr/>
+          <p:nvPr/>
+        </p:nvSpPr>
+        <p:spPr>
+          <a:xfrm>
+            <a:off x="850392" y="1737360"/>
+            <a:ext cx="402336" cy="402336"/>
+          </a:xfrm>
+          <a:prstGeom prst="rect">
+            <a:avLst/>
+          </a:prstGeom>
+          <a:noFill/>
+          <a:ln/>
+        </p:spPr>
+        <p:txBody>
+          <a:bodyPr wrap="square" lIns="0" tIns="0" rIns="0" bIns="0" rtlCol="0" anchor="ctr"/>
+          <a:lstStyle/>
+          <a:p>
+            <a:pPr marL="0" indent="0" algn="ctr">
+              <a:buNone/>
+            </a:pPr>
+            <a:r>
+              <a:rPr lang="en-US" sz="1500" b="1" dirty="0">
+                <a:solidFill>
+                  <a:srgbClr val="FFFFFF"/>
+                </a:solidFill>
+                <a:latin typeface="TH Sarabun New" pitchFamily="34" charset="0"/>
+                <a:ea typeface="TH Sarabun New" pitchFamily="34" charset="-122"/>
+                <a:cs typeface="TH Sarabun New" pitchFamily="34" charset="-120"/>
+              </a:rPr>
+              <a:t>1</a:t>
+            </a:r>
+            <a:endParaRPr lang="en-US" sz="1500" dirty="0"/>
+          </a:p>
+        </p:txBody>
+      </p:sp>
+      <p:sp>
+        <p:nvSpPr>
+          <p:cNvPr id="8" name="Text 6"/>
+          <p:cNvSpPr/>
+          <p:nvPr/>
+        </p:nvSpPr>
+        <p:spPr>
+          <a:xfrm>
+            <a:off x="1380744" y="1700784"/>
+            <a:ext cx="4389120" cy="384048"/>
+          </a:xfrm>
+          <a:prstGeom prst="rect">
+            <a:avLst/>
+          </a:prstGeom>
+          <a:noFill/>
+          <a:ln/>
+        </p:spPr>
+        <p:txBody>
+          <a:bodyPr wrap="square" lIns="0" tIns="0" rIns="0" bIns="0" rtlCol="0" anchor="ctr"/>
+          <a:lstStyle/>
+          <a:p>
+            <a:pPr marL="0" indent="0">
+              <a:buNone/>
+            </a:pPr>
+            <a:r>
+              <a:rPr lang="en-US" sz="1900" b="1" dirty="0">
+                <a:solidFill>
+                  <a:srgbClr val="222831"/>
+                </a:solidFill>
+                <a:latin typeface="TH Sarabun New" pitchFamily="34" charset="0"/>
+                <a:ea typeface="TH Sarabun New" pitchFamily="34" charset="-122"/>
+                <a:cs typeface="TH Sarabun New" pitchFamily="34" charset="-120"/>
+              </a:rPr>
+              <a:t>เข้าใจโครงสร้างเว็บแอปพลิเคชัน</a:t>
+            </a:r>
+            <a:endParaRPr lang="en-US" sz="1900" dirty="0"/>
+          </a:p>
+        </p:txBody>
+      </p:sp>
+      <p:sp>
+        <p:nvSpPr>
+          <p:cNvPr id="9" name="Text 7"/>
+          <p:cNvSpPr/>
+          <p:nvPr/>
+        </p:nvSpPr>
+        <p:spPr>
+          <a:xfrm>
+            <a:off x="1380744" y="2121408"/>
+            <a:ext cx="4389120" cy="566928"/>
+          </a:xfrm>
+          <a:prstGeom prst="rect">
+            <a:avLst/>
+          </a:prstGeom>
+          <a:noFill/>
+          <a:ln/>
+        </p:spPr>
+        <p:txBody>
+          <a:bodyPr wrap="square" lIns="0" tIns="0" rIns="0" bIns="0" rtlCol="0" anchor="t"/>
+          <a:lstStyle/>
+          <a:p>
+            <a:pPr marL="0" indent="0">
+              <a:buNone/>
+            </a:pPr>
+            <a:r>
+              <a:rPr lang="en-US" sz="1550" dirty="0">
+                <a:solidFill>
+                  <a:srgbClr val="393E46"/>
+                </a:solidFill>
+                <a:latin typeface="TH Sarabun New" pitchFamily="34" charset="0"/>
+                <a:ea typeface="TH Sarabun New" pitchFamily="34" charset="-122"/>
+                <a:cs typeface="TH Sarabun New" pitchFamily="34" charset="-120"/>
+              </a:rPr>
+              <a:t>แยกออกว่า Frontend / Backend / Database ทำหน้าที่ต่างกันอย่างไร</a:t>
+            </a:r>
+            <a:endParaRPr lang="en-US" sz="1550" dirty="0"/>
+          </a:p>
+        </p:txBody>
+      </p:sp>
+      <p:sp>
+        <p:nvSpPr>
+          <p:cNvPr id="10" name="Shape 8"/>
+          <p:cNvSpPr/>
+          <p:nvPr/>
+        </p:nvSpPr>
+        <p:spPr>
+          <a:xfrm>
+            <a:off x="6227064" y="1481328"/>
+            <a:ext cx="5340096" cy="1371600"/>
+          </a:xfrm>
+          <a:prstGeom prst="roundRect">
+            <a:avLst>
+              <a:gd name="adj" fmla="val 6000"/>
+            </a:avLst>
+          </a:prstGeom>
+          <a:solidFill>
+            <a:srgbClr val="F5F7F8"/>
+          </a:solidFill>
+          <a:ln w="9525">
+            <a:solidFill>
+              <a:srgbClr val="F5F7F8"/>
+            </a:solidFill>
+            <a:prstDash val="solid"/>
+          </a:ln>
+          <a:effectLst>
+            <a:outerShdw blurRad="101600" dist="12700" dir="5400000" algn="bl" rotWithShape="0">
+              <a:srgbClr val="222831">
+                <a:alpha val="10000"/>
+              </a:srgbClr>
+            </a:outerShdw>
+          </a:effectLst>
+        </p:spPr>
+        <p:txBody>
+          <a:bodyPr/>
+          <a:lstStyle/>
+          <a:p>
+            <a:endParaRPr lang="en-TH"/>
+          </a:p>
+        </p:txBody>
+      </p:sp>
+      <p:sp>
+        <p:nvSpPr>
+          <p:cNvPr id="11" name="Shape 9"/>
+          <p:cNvSpPr/>
+          <p:nvPr/>
+        </p:nvSpPr>
+        <p:spPr>
+          <a:xfrm>
+            <a:off x="6483096" y="1737360"/>
+            <a:ext cx="402336" cy="402336"/>
+          </a:xfrm>
+          <a:prstGeom prst="ellipse">
+            <a:avLst/>
+          </a:prstGeom>
+          <a:solidFill>
+            <a:srgbClr val="00ADB5"/>
+          </a:solidFill>
+          <a:ln w="12700">
+            <a:solidFill>
+              <a:srgbClr val="00ADB5"/>
+            </a:solidFill>
+            <a:prstDash val="solid"/>
+          </a:ln>
+        </p:spPr>
+        <p:txBody>
+          <a:bodyPr/>
+          <a:lstStyle/>
+          <a:p>
+            <a:endParaRPr lang="en-TH"/>
+          </a:p>
+        </p:txBody>
+      </p:sp>
+      <p:sp>
+        <p:nvSpPr>
+          <p:cNvPr id="12" name="Text 10"/>
+          <p:cNvSpPr/>
+          <p:nvPr/>
+        </p:nvSpPr>
+        <p:spPr>
+          <a:xfrm>
+            <a:off x="6483096" y="1737360"/>
+            <a:ext cx="402336" cy="402336"/>
+          </a:xfrm>
+          <a:prstGeom prst="rect">
+            <a:avLst/>
+          </a:prstGeom>
+          <a:noFill/>
+          <a:ln/>
+        </p:spPr>
+        <p:txBody>
+          <a:bodyPr wrap="square" lIns="0" tIns="0" rIns="0" bIns="0" rtlCol="0" anchor="ctr"/>
+          <a:lstStyle/>
+          <a:p>
+            <a:pPr marL="0" indent="0" algn="ctr">
+              <a:buNone/>
+            </a:pPr>
+            <a:r>
+              <a:rPr lang="en-US" sz="1500" b="1" dirty="0">
+                <a:solidFill>
+                  <a:srgbClr val="FFFFFF"/>
+                </a:solidFill>
+                <a:latin typeface="TH Sarabun New" pitchFamily="34" charset="0"/>
+                <a:ea typeface="TH Sarabun New" pitchFamily="34" charset="-122"/>
+                <a:cs typeface="TH Sarabun New" pitchFamily="34" charset="-120"/>
+              </a:rPr>
+              <a:t>2</a:t>
+            </a:r>
+            <a:endParaRPr lang="en-US" sz="1500" dirty="0"/>
+          </a:p>
+        </p:txBody>
+      </p:sp>
+      <p:sp>
+        <p:nvSpPr>
+          <p:cNvPr id="13" name="Text 11"/>
+          <p:cNvSpPr/>
+          <p:nvPr/>
+        </p:nvSpPr>
+        <p:spPr>
+          <a:xfrm>
+            <a:off x="7013448" y="1700784"/>
+            <a:ext cx="4389120" cy="384048"/>
+          </a:xfrm>
+          <a:prstGeom prst="rect">
+            <a:avLst/>
+          </a:prstGeom>
+          <a:noFill/>
+          <a:ln/>
+        </p:spPr>
+        <p:txBody>
+          <a:bodyPr wrap="square" lIns="0" tIns="0" rIns="0" bIns="0" rtlCol="0" anchor="ctr"/>
+          <a:lstStyle/>
+          <a:p>
+            <a:pPr marL="0" indent="0">
+              <a:buNone/>
+            </a:pPr>
+            <a:r>
+              <a:rPr lang="en-US" sz="1900" b="1" dirty="0">
+                <a:solidFill>
+                  <a:srgbClr val="222831"/>
+                </a:solidFill>
+                <a:latin typeface="TH Sarabun New" pitchFamily="34" charset="0"/>
+                <a:ea typeface="TH Sarabun New" pitchFamily="34" charset="-122"/>
+                <a:cs typeface="TH Sarabun New" pitchFamily="34" charset="-120"/>
+              </a:rPr>
+              <a:t>สั่งงาน AI Agent ด้วย Antigravity</a:t>
+            </a:r>
+            <a:endParaRPr lang="en-US" sz="1900" dirty="0"/>
+          </a:p>
+        </p:txBody>
+      </p:sp>
+      <p:sp>
+        <p:nvSpPr>
+          <p:cNvPr id="14" name="Text 12"/>
+          <p:cNvSpPr/>
+          <p:nvPr/>
+        </p:nvSpPr>
+        <p:spPr>
+          <a:xfrm>
+            <a:off x="7013448" y="2121408"/>
+            <a:ext cx="4389120" cy="566928"/>
+          </a:xfrm>
+          <a:prstGeom prst="rect">
+            <a:avLst/>
+          </a:prstGeom>
+          <a:noFill/>
+          <a:ln/>
+        </p:spPr>
+        <p:txBody>
+          <a:bodyPr wrap="square" lIns="0" tIns="0" rIns="0" bIns="0" rtlCol="0" anchor="t"/>
+          <a:lstStyle/>
+          <a:p>
+            <a:pPr marL="0" indent="0">
+              <a:buNone/>
+            </a:pPr>
+            <a:r>
+              <a:rPr lang="en-US" sz="1550" dirty="0">
+                <a:solidFill>
+                  <a:srgbClr val="393E46"/>
+                </a:solidFill>
+                <a:latin typeface="TH Sarabun New" pitchFamily="34" charset="0"/>
+                <a:ea typeface="TH Sarabun New" pitchFamily="34" charset="-122"/>
+                <a:cs typeface="TH Sarabun New" pitchFamily="34" charset="-120"/>
+              </a:rPr>
+              <a:t>รู้จัก Editor, Agent, Artifacts และ Browser Subagent</a:t>
+            </a:r>
+            <a:endParaRPr lang="en-US" sz="1550" dirty="0"/>
+          </a:p>
+        </p:txBody>
+      </p:sp>
+      <p:sp>
+        <p:nvSpPr>
+          <p:cNvPr id="15" name="Shape 13"/>
+          <p:cNvSpPr/>
+          <p:nvPr/>
+        </p:nvSpPr>
+        <p:spPr>
+          <a:xfrm>
+            <a:off x="594360" y="3054096"/>
+            <a:ext cx="5340096" cy="1371600"/>
+          </a:xfrm>
+          <a:prstGeom prst="roundRect">
+            <a:avLst>
+              <a:gd name="adj" fmla="val 6000"/>
+            </a:avLst>
+          </a:prstGeom>
+          <a:solidFill>
+            <a:srgbClr val="F5F7F8"/>
+          </a:solidFill>
+          <a:ln w="9525">
+            <a:solidFill>
+              <a:srgbClr val="F5F7F8"/>
+            </a:solidFill>
+            <a:prstDash val="solid"/>
+          </a:ln>
+          <a:effectLst>
+            <a:outerShdw blurRad="101600" dist="12700" dir="5400000" algn="bl" rotWithShape="0">
+              <a:srgbClr val="222831">
+                <a:alpha val="10000"/>
+              </a:srgbClr>
+            </a:outerShdw>
+          </a:effectLst>
+        </p:spPr>
+        <p:txBody>
+          <a:bodyPr/>
+          <a:lstStyle/>
+          <a:p>
+            <a:endParaRPr lang="en-TH"/>
+          </a:p>
+        </p:txBody>
+      </p:sp>
+      <p:sp>
+        <p:nvSpPr>
+          <p:cNvPr id="16" name="Shape 14"/>
+          <p:cNvSpPr/>
+          <p:nvPr/>
+        </p:nvSpPr>
+        <p:spPr>
+          <a:xfrm>
+            <a:off x="850392" y="3310128"/>
+            <a:ext cx="402336" cy="402336"/>
+          </a:xfrm>
+          <a:prstGeom prst="ellipse">
+            <a:avLst/>
+          </a:prstGeom>
+          <a:solidFill>
+            <a:srgbClr val="00ADB5"/>
+          </a:solidFill>
+          <a:ln w="12700">
+            <a:solidFill>
+              <a:srgbClr val="00ADB5"/>
+            </a:solidFill>
+            <a:prstDash val="solid"/>
+          </a:ln>
+        </p:spPr>
+        <p:txBody>
+          <a:bodyPr/>
+          <a:lstStyle/>
+          <a:p>
+            <a:endParaRPr lang="en-TH"/>
+          </a:p>
+        </p:txBody>
+      </p:sp>
+      <p:sp>
+        <p:nvSpPr>
+          <p:cNvPr id="17" name="Text 15"/>
+          <p:cNvSpPr/>
+          <p:nvPr/>
+        </p:nvSpPr>
+        <p:spPr>
+          <a:xfrm>
+            <a:off x="850392" y="3310128"/>
+            <a:ext cx="402336" cy="402336"/>
+          </a:xfrm>
+          <a:prstGeom prst="rect">
+            <a:avLst/>
+          </a:prstGeom>
+          <a:noFill/>
+          <a:ln/>
+        </p:spPr>
+        <p:txBody>
+          <a:bodyPr wrap="square" lIns="0" tIns="0" rIns="0" bIns="0" rtlCol="0" anchor="ctr"/>
+          <a:lstStyle/>
+          <a:p>
+            <a:pPr marL="0" indent="0" algn="ctr">
+              <a:buNone/>
+            </a:pPr>
+            <a:r>
+              <a:rPr lang="en-US" sz="1500" b="1" dirty="0">
+                <a:solidFill>
+                  <a:srgbClr val="FFFFFF"/>
+                </a:solidFill>
+                <a:latin typeface="TH Sarabun New" pitchFamily="34" charset="0"/>
+                <a:ea typeface="TH Sarabun New" pitchFamily="34" charset="-122"/>
+                <a:cs typeface="TH Sarabun New" pitchFamily="34" charset="-120"/>
+              </a:rPr>
+              <a:t>3</a:t>
+            </a:r>
+            <a:endParaRPr lang="en-US" sz="1500" dirty="0"/>
+          </a:p>
+        </p:txBody>
+      </p:sp>
+      <p:sp>
+        <p:nvSpPr>
+          <p:cNvPr id="18" name="Text 16"/>
+          <p:cNvSpPr/>
+          <p:nvPr/>
+        </p:nvSpPr>
+        <p:spPr>
+          <a:xfrm>
+            <a:off x="1380744" y="3273552"/>
+            <a:ext cx="4389120" cy="384048"/>
+          </a:xfrm>
+          <a:prstGeom prst="rect">
+            <a:avLst/>
+          </a:prstGeom>
+          <a:noFill/>
+          <a:ln/>
+        </p:spPr>
+        <p:txBody>
+          <a:bodyPr wrap="square" lIns="0" tIns="0" rIns="0" bIns="0" rtlCol="0" anchor="ctr"/>
+          <a:lstStyle/>
+          <a:p>
+            <a:pPr marL="0" indent="0">
+              <a:buNone/>
+            </a:pPr>
+            <a:r>
+              <a:rPr lang="en-US" sz="1900" b="1" dirty="0">
+                <a:solidFill>
+                  <a:srgbClr val="222831"/>
+                </a:solidFill>
+                <a:latin typeface="TH Sarabun New" pitchFamily="34" charset="0"/>
+                <a:ea typeface="TH Sarabun New" pitchFamily="34" charset="-122"/>
+                <a:cs typeface="TH Sarabun New" pitchFamily="34" charset="-120"/>
+              </a:rPr>
+              <a:t>เขียนสเปกที่ AI ทำตามได้จริง</a:t>
+            </a:r>
+            <a:endParaRPr lang="en-US" sz="1900" dirty="0"/>
+          </a:p>
+        </p:txBody>
+      </p:sp>
+      <p:sp>
+        <p:nvSpPr>
+          <p:cNvPr id="19" name="Text 17"/>
+          <p:cNvSpPr/>
+          <p:nvPr/>
+        </p:nvSpPr>
+        <p:spPr>
+          <a:xfrm>
+            <a:off x="1380744" y="3694176"/>
+            <a:ext cx="4389120" cy="566928"/>
+          </a:xfrm>
+          <a:prstGeom prst="rect">
+            <a:avLst/>
+          </a:prstGeom>
+          <a:noFill/>
+          <a:ln/>
+        </p:spPr>
+        <p:txBody>
+          <a:bodyPr wrap="square" lIns="0" tIns="0" rIns="0" bIns="0" rtlCol="0" anchor="t"/>
+          <a:lstStyle/>
+          <a:p>
+            <a:pPr marL="0" indent="0">
+              <a:buNone/>
+            </a:pPr>
+            <a:r>
+              <a:rPr lang="en-US" sz="1550" dirty="0">
+                <a:solidFill>
+                  <a:srgbClr val="393E46"/>
+                </a:solidFill>
+                <a:latin typeface="TH Sarabun New" pitchFamily="34" charset="0"/>
+                <a:ea typeface="TH Sarabun New" pitchFamily="34" charset="-122"/>
+                <a:cs typeface="TH Sarabun New" pitchFamily="34" charset="-120"/>
+              </a:rPr>
+              <a:t>แปลงโจทย์เป็นเอกสารสเปกไฟล์เดียว พร้อมเกณฑ์ยอมรับที่วัดผลได้</a:t>
+            </a:r>
+            <a:endParaRPr lang="en-US" sz="1550" dirty="0"/>
+          </a:p>
+        </p:txBody>
+      </p:sp>
+      <p:sp>
+        <p:nvSpPr>
+          <p:cNvPr id="20" name="Shape 18"/>
+          <p:cNvSpPr/>
+          <p:nvPr/>
+        </p:nvSpPr>
+        <p:spPr>
+          <a:xfrm>
+            <a:off x="6227064" y="3054096"/>
+            <a:ext cx="5340096" cy="1371600"/>
+          </a:xfrm>
+          <a:prstGeom prst="roundRect">
+            <a:avLst>
+              <a:gd name="adj" fmla="val 6000"/>
+            </a:avLst>
+          </a:prstGeom>
+          <a:solidFill>
+            <a:srgbClr val="F5F7F8"/>
+          </a:solidFill>
+          <a:ln w="9525">
+            <a:solidFill>
+              <a:srgbClr val="F5F7F8"/>
+            </a:solidFill>
+            <a:prstDash val="solid"/>
+          </a:ln>
+          <a:effectLst>
+            <a:outerShdw blurRad="101600" dist="12700" dir="5400000" algn="bl" rotWithShape="0">
+              <a:srgbClr val="222831">
+                <a:alpha val="10000"/>
+              </a:srgbClr>
+            </a:outerShdw>
+          </a:effectLst>
+        </p:spPr>
+        <p:txBody>
+          <a:bodyPr/>
+          <a:lstStyle/>
+          <a:p>
+            <a:endParaRPr lang="en-TH"/>
+          </a:p>
+        </p:txBody>
+      </p:sp>
+      <p:sp>
+        <p:nvSpPr>
+          <p:cNvPr id="21" name="Shape 19"/>
+          <p:cNvSpPr/>
+          <p:nvPr/>
+        </p:nvSpPr>
+        <p:spPr>
+          <a:xfrm>
+            <a:off x="6483096" y="3310128"/>
+            <a:ext cx="402336" cy="402336"/>
+          </a:xfrm>
+          <a:prstGeom prst="ellipse">
+            <a:avLst/>
+          </a:prstGeom>
+          <a:solidFill>
+            <a:srgbClr val="00ADB5"/>
+          </a:solidFill>
+          <a:ln w="12700">
+            <a:solidFill>
+              <a:srgbClr val="00ADB5"/>
+            </a:solidFill>
+            <a:prstDash val="solid"/>
+          </a:ln>
+        </p:spPr>
+        <p:txBody>
+          <a:bodyPr/>
+          <a:lstStyle/>
+          <a:p>
+            <a:endParaRPr lang="en-TH"/>
+          </a:p>
+        </p:txBody>
+      </p:sp>
+      <p:sp>
+        <p:nvSpPr>
+          <p:cNvPr id="22" name="Text 20"/>
+          <p:cNvSpPr/>
+          <p:nvPr/>
+        </p:nvSpPr>
+        <p:spPr>
+          <a:xfrm>
+            <a:off x="6483096" y="3310128"/>
+            <a:ext cx="402336" cy="402336"/>
+          </a:xfrm>
+          <a:prstGeom prst="rect">
+            <a:avLst/>
+          </a:prstGeom>
+          <a:noFill/>
+          <a:ln/>
+        </p:spPr>
+        <p:txBody>
+          <a:bodyPr wrap="square" lIns="0" tIns="0" rIns="0" bIns="0" rtlCol="0" anchor="ctr"/>
+          <a:lstStyle/>
+          <a:p>
+            <a:pPr marL="0" indent="0" algn="ctr">
+              <a:buNone/>
+            </a:pPr>
+            <a:r>
+              <a:rPr lang="en-US" sz="1500" b="1" dirty="0">
+                <a:solidFill>
+                  <a:srgbClr val="FFFFFF"/>
+                </a:solidFill>
+                <a:latin typeface="TH Sarabun New" pitchFamily="34" charset="0"/>
+                <a:ea typeface="TH Sarabun New" pitchFamily="34" charset="-122"/>
+                <a:cs typeface="TH Sarabun New" pitchFamily="34" charset="-120"/>
+              </a:rPr>
+              <a:t>4</a:t>
+            </a:r>
+            <a:endParaRPr lang="en-US" sz="1500" dirty="0"/>
+          </a:p>
+        </p:txBody>
+      </p:sp>
+      <p:sp>
+        <p:nvSpPr>
+          <p:cNvPr id="23" name="Text 21"/>
+          <p:cNvSpPr/>
+          <p:nvPr/>
+        </p:nvSpPr>
+        <p:spPr>
+          <a:xfrm>
+            <a:off x="7013448" y="3273552"/>
+            <a:ext cx="4389120" cy="384048"/>
+          </a:xfrm>
+          <a:prstGeom prst="rect">
+            <a:avLst/>
+          </a:prstGeom>
+          <a:noFill/>
+          <a:ln/>
+        </p:spPr>
+        <p:txBody>
+          <a:bodyPr wrap="square" lIns="0" tIns="0" rIns="0" bIns="0" rtlCol="0" anchor="ctr"/>
+          <a:lstStyle/>
+          <a:p>
+            <a:pPr marL="0" indent="0">
+              <a:buNone/>
+            </a:pPr>
+            <a:r>
+              <a:rPr lang="en-US" sz="1900" b="1" dirty="0">
+                <a:solidFill>
+                  <a:srgbClr val="222831"/>
+                </a:solidFill>
+                <a:latin typeface="TH Sarabun New" pitchFamily="34" charset="0"/>
+                <a:ea typeface="TH Sarabun New" pitchFamily="34" charset="-122"/>
+                <a:cs typeface="TH Sarabun New" pitchFamily="34" charset="-120"/>
+              </a:rPr>
+              <a:t>สร้างเว็บที่ใช้งานได้จริงและนำขึ้นระบบ</a:t>
+            </a:r>
+            <a:endParaRPr lang="en-US" sz="1900" dirty="0"/>
+          </a:p>
+        </p:txBody>
+      </p:sp>
+      <p:sp>
+        <p:nvSpPr>
+          <p:cNvPr id="24" name="Text 22"/>
+          <p:cNvSpPr/>
+          <p:nvPr/>
+        </p:nvSpPr>
+        <p:spPr>
+          <a:xfrm>
+            <a:off x="7013448" y="3694176"/>
+            <a:ext cx="4389120" cy="566928"/>
+          </a:xfrm>
+          <a:prstGeom prst="rect">
+            <a:avLst/>
+          </a:prstGeom>
+          <a:noFill/>
+          <a:ln/>
+        </p:spPr>
+        <p:txBody>
+          <a:bodyPr wrap="square" lIns="0" tIns="0" rIns="0" bIns="0" rtlCol="0" anchor="t"/>
+          <a:lstStyle/>
+          <a:p>
+            <a:pPr marL="0" indent="0">
+              <a:buNone/>
+            </a:pPr>
+            <a:r>
+              <a:rPr lang="en-US" sz="1550" dirty="0">
+                <a:solidFill>
+                  <a:srgbClr val="393E46"/>
+                </a:solidFill>
+                <a:latin typeface="TH Sarabun New" pitchFamily="34" charset="0"/>
+                <a:ea typeface="TH Sarabun New" pitchFamily="34" charset="-122"/>
+                <a:cs typeface="TH Sarabun New" pitchFamily="34" charset="-120"/>
+              </a:rPr>
+              <a:t>ครบ 4 หน้า เชื่อมฐานข้อมูลจริง และเปิดจาก URL สาธารณะ</a:t>
+            </a:r>
+            <a:endParaRPr lang="en-US" sz="1550" dirty="0"/>
+          </a:p>
+        </p:txBody>
+      </p:sp>
+    </p:spTree>
+  </p:cSld>
+  <p:clrMapOvr>
+    <a:masterClrMapping/>
+  </p:clrMapOvr>
+</p:sld>
+</file>
+
+<file path=ppt/slides/slide30.xml><?xml version="1.0" encoding="utf-8"?>
 <p:sld xmlns:a="http://schemas.openxmlformats.org/drawingml/2006/main" xmlns:r="http://schemas.openxmlformats.org/officeDocument/2006/relationships" xmlns:p="http://schemas.openxmlformats.org/presentationml/2006/main">
   <p:cSld name="Slide 38">
     <p:bg>
@@ -17784,7 +19061,7 @@
 </p:sld>
 </file>
 
-<file path=ppt/slides/slide3.xml><?xml version="1.0" encoding="utf-8"?>
+<file path=ppt/slides/slide4.xml><?xml version="1.0" encoding="utf-8"?>
 <p:sld xmlns:a="http://schemas.openxmlformats.org/drawingml/2006/main" xmlns:r="http://schemas.openxmlformats.org/officeDocument/2006/relationships" xmlns:p="http://schemas.openxmlformats.org/presentationml/2006/main">
   <p:cSld name="Slide 4">
     <p:bg>
@@ -18005,7 +19282,7 @@
 </p:sld>
 </file>
 
-<file path=ppt/slides/slide4.xml><?xml version="1.0" encoding="utf-8"?>
+<file path=ppt/slides/slide5.xml><?xml version="1.0" encoding="utf-8"?>
 <p:sld xmlns:a="http://schemas.openxmlformats.org/drawingml/2006/main" xmlns:r="http://schemas.openxmlformats.org/officeDocument/2006/relationships" xmlns:p="http://schemas.openxmlformats.org/presentationml/2006/main">
   <p:cSld name="Slide 5">
     <p:bg>
@@ -18561,7 +19838,7 @@
 </p:sld>
 </file>
 
-<file path=ppt/slides/slide5.xml><?xml version="1.0" encoding="utf-8"?>
+<file path=ppt/slides/slide6.xml><?xml version="1.0" encoding="utf-8"?>
 <p:sld xmlns:a="http://schemas.openxmlformats.org/drawingml/2006/main" xmlns:r="http://schemas.openxmlformats.org/officeDocument/2006/relationships" xmlns:p="http://schemas.openxmlformats.org/presentationml/2006/main">
   <p:cSld name="Slide 6">
     <p:bg>
@@ -19548,7 +20825,7 @@
 </p:sld>
 </file>
 
-<file path=ppt/slides/slide6.xml><?xml version="1.0" encoding="utf-8"?>
+<file path=ppt/slides/slide7.xml><?xml version="1.0" encoding="utf-8"?>
 <p:sld xmlns:a="http://schemas.openxmlformats.org/drawingml/2006/main" xmlns:r="http://schemas.openxmlformats.org/officeDocument/2006/relationships" xmlns:p="http://schemas.openxmlformats.org/presentationml/2006/main">
   <p:cSld name="Slide 7">
     <p:bg>
@@ -20379,7 +21656,7 @@
 </p:sld>
 </file>
 
-<file path=ppt/slides/slide7.xml><?xml version="1.0" encoding="utf-8"?>
+<file path=ppt/slides/slide8.xml><?xml version="1.0" encoding="utf-8"?>
 <p:sld xmlns:a="http://schemas.openxmlformats.org/drawingml/2006/main" xmlns:r="http://schemas.openxmlformats.org/officeDocument/2006/relationships" xmlns:p="http://schemas.openxmlformats.org/presentationml/2006/main">
   <p:cSld name="Slide 8">
     <p:bg>
@@ -21732,7 +23009,7 @@
 </p:sld>
 </file>
 
-<file path=ppt/slides/slide8.xml><?xml version="1.0" encoding="utf-8"?>
+<file path=ppt/slides/slide9.xml><?xml version="1.0" encoding="utf-8"?>
 <p:sld xmlns:a="http://schemas.openxmlformats.org/drawingml/2006/main" xmlns:r="http://schemas.openxmlformats.org/officeDocument/2006/relationships" xmlns:p="http://schemas.openxmlformats.org/presentationml/2006/main">
   <p:cSld name="Slide 9">
     <p:bg>
@@ -23204,1179 +24481,6 @@
               <a:t>AI Agent ที่เขียนโค้ดให้เรา</a:t>
             </a:r>
             <a:endParaRPr lang="en-US" sz="1600" dirty="0"/>
-          </a:p>
-        </p:txBody>
-      </p:sp>
-    </p:spTree>
-  </p:cSld>
-  <p:clrMapOvr>
-    <a:masterClrMapping/>
-  </p:clrMapOvr>
-</p:sld>
-</file>
-
-<file path=ppt/slides/slide9.xml><?xml version="1.0" encoding="utf-8"?>
-<p:sld xmlns:a="http://schemas.openxmlformats.org/drawingml/2006/main" xmlns:r="http://schemas.openxmlformats.org/officeDocument/2006/relationships" xmlns:p="http://schemas.openxmlformats.org/presentationml/2006/main">
-  <p:cSld name="Slide 10">
-    <p:bg>
-      <p:bgPr>
-        <a:solidFill>
-          <a:srgbClr val="E8F6F7"/>
-        </a:solidFill>
-        <a:effectLst/>
-      </p:bgPr>
-    </p:bg>
-    <p:spTree>
-      <p:nvGrpSpPr>
-        <p:cNvPr id="1" name=""/>
-        <p:cNvGrpSpPr/>
-        <p:nvPr/>
-      </p:nvGrpSpPr>
-      <p:grpSpPr>
-        <a:xfrm>
-          <a:off x="0" y="0"/>
-          <a:ext cx="0" cy="0"/>
-          <a:chOff x="0" y="0"/>
-          <a:chExt cx="0" cy="0"/>
-        </a:xfrm>
-      </p:grpSpPr>
-      <p:sp>
-        <p:nvSpPr>
-          <p:cNvPr id="2" name="Text 0"/>
-          <p:cNvSpPr/>
-          <p:nvPr/>
-        </p:nvSpPr>
-        <p:spPr>
-          <a:xfrm>
-            <a:off x="11018520" y="6263640"/>
-            <a:ext cx="548640" cy="274320"/>
-          </a:xfrm>
-          <a:prstGeom prst="rect">
-            <a:avLst/>
-          </a:prstGeom>
-          <a:noFill/>
-          <a:ln/>
-        </p:spPr>
-        <p:txBody>
-          <a:bodyPr wrap="square" lIns="0" tIns="0" rIns="0" bIns="0" rtlCol="0" anchor="ctr"/>
-          <a:lstStyle/>
-          <a:p>
-            <a:pPr marL="0" indent="0" algn="r">
-              <a:buNone/>
-            </a:pPr>
-            <a:r>
-              <a:rPr lang="en-US" sz="1200" dirty="0">
-                <a:solidFill>
-                  <a:srgbClr val="9AA3AD"/>
-                </a:solidFill>
-                <a:latin typeface="TH Sarabun New" pitchFamily="34" charset="0"/>
-                <a:ea typeface="TH Sarabun New" pitchFamily="34" charset="-122"/>
-                <a:cs typeface="TH Sarabun New" pitchFamily="34" charset="-120"/>
-              </a:rPr>
-              <a:t>10</a:t>
-            </a:r>
-            <a:endParaRPr lang="en-US" sz="1200" dirty="0"/>
-          </a:p>
-        </p:txBody>
-      </p:sp>
-      <p:sp>
-        <p:nvSpPr>
-          <p:cNvPr id="3" name="Shape 1"/>
-          <p:cNvSpPr/>
-          <p:nvPr/>
-        </p:nvSpPr>
-        <p:spPr>
-          <a:xfrm>
-            <a:off x="594360" y="310896"/>
-            <a:ext cx="1481328" cy="475488"/>
-          </a:xfrm>
-          <a:prstGeom prst="roundRect">
-            <a:avLst>
-              <a:gd name="adj" fmla="val 50000"/>
-            </a:avLst>
-          </a:prstGeom>
-          <a:solidFill>
-            <a:srgbClr val="00ADB5"/>
-          </a:solidFill>
-          <a:ln w="12700">
-            <a:solidFill>
-              <a:srgbClr val="00ADB5"/>
-            </a:solidFill>
-            <a:prstDash val="solid"/>
-          </a:ln>
-        </p:spPr>
-        <p:txBody>
-          <a:bodyPr/>
-          <a:lstStyle/>
-          <a:p>
-            <a:endParaRPr lang="en-TH"/>
-          </a:p>
-        </p:txBody>
-      </p:sp>
-      <p:sp>
-        <p:nvSpPr>
-          <p:cNvPr id="4" name="Text 2"/>
-          <p:cNvSpPr/>
-          <p:nvPr/>
-        </p:nvSpPr>
-        <p:spPr>
-          <a:xfrm>
-            <a:off x="594360" y="310896"/>
-            <a:ext cx="1481328" cy="475488"/>
-          </a:xfrm>
-          <a:prstGeom prst="rect">
-            <a:avLst/>
-          </a:prstGeom>
-          <a:noFill/>
-          <a:ln/>
-        </p:spPr>
-        <p:txBody>
-          <a:bodyPr wrap="square" lIns="0" tIns="0" rIns="0" bIns="0" rtlCol="0" anchor="ctr"/>
-          <a:lstStyle/>
-          <a:p>
-            <a:pPr marL="0" indent="0" algn="ctr">
-              <a:buNone/>
-            </a:pPr>
-            <a:r>
-              <a:rPr lang="en-US" sz="1800" b="1" dirty="0">
-                <a:solidFill>
-                  <a:srgbClr val="FFFFFF"/>
-                </a:solidFill>
-                <a:latin typeface="TH Sarabun New" pitchFamily="34" charset="0"/>
-                <a:ea typeface="TH Sarabun New" pitchFamily="34" charset="-122"/>
-                <a:cs typeface="TH Sarabun New" pitchFamily="34" charset="-120"/>
-              </a:rPr>
-              <a:t>LAB A</a:t>
-            </a:r>
-            <a:endParaRPr lang="en-US" sz="1800" dirty="0"/>
-          </a:p>
-        </p:txBody>
-      </p:sp>
-      <p:sp>
-        <p:nvSpPr>
-          <p:cNvPr id="5" name="Text 3"/>
-          <p:cNvSpPr/>
-          <p:nvPr/>
-        </p:nvSpPr>
-        <p:spPr>
-          <a:xfrm>
-            <a:off x="2286000" y="274320"/>
-            <a:ext cx="7315200" cy="548640"/>
-          </a:xfrm>
-          <a:prstGeom prst="rect">
-            <a:avLst/>
-          </a:prstGeom>
-          <a:noFill/>
-          <a:ln/>
-        </p:spPr>
-        <p:txBody>
-          <a:bodyPr wrap="square" lIns="0" tIns="0" rIns="0" bIns="0" rtlCol="0" anchor="ctr"/>
-          <a:lstStyle/>
-          <a:p>
-            <a:pPr marL="0" indent="0">
-              <a:buNone/>
-            </a:pPr>
-            <a:r>
-              <a:rPr lang="en-US" sz="3000" b="1" dirty="0">
-                <a:solidFill>
-                  <a:srgbClr val="222831"/>
-                </a:solidFill>
-                <a:latin typeface="TH Sarabun New" pitchFamily="34" charset="0"/>
-                <a:ea typeface="TH Sarabun New" pitchFamily="34" charset="-122"/>
-                <a:cs typeface="TH Sarabun New" pitchFamily="34" charset="-120"/>
-              </a:rPr>
-              <a:t>เตรียมเครื่องและเปิดโปรเจกต์</a:t>
-            </a:r>
-            <a:endParaRPr lang="en-US" sz="3000" dirty="0"/>
-          </a:p>
-        </p:txBody>
-      </p:sp>
-      <p:sp>
-        <p:nvSpPr>
-          <p:cNvPr id="6" name="Text 4"/>
-          <p:cNvSpPr/>
-          <p:nvPr/>
-        </p:nvSpPr>
-        <p:spPr>
-          <a:xfrm>
-            <a:off x="9738360" y="310896"/>
-            <a:ext cx="1828800" cy="475488"/>
-          </a:xfrm>
-          <a:prstGeom prst="rect">
-            <a:avLst/>
-          </a:prstGeom>
-          <a:noFill/>
-          <a:ln/>
-        </p:spPr>
-        <p:txBody>
-          <a:bodyPr wrap="square" lIns="0" tIns="0" rIns="0" bIns="0" rtlCol="0" anchor="ctr"/>
-          <a:lstStyle/>
-          <a:p>
-            <a:pPr marL="0" indent="0" algn="r">
-              <a:buNone/>
-            </a:pPr>
-            <a:r>
-              <a:rPr lang="en-US" sz="1700" dirty="0">
-                <a:solidFill>
-                  <a:srgbClr val="393E46"/>
-                </a:solidFill>
-                <a:latin typeface="TH Sarabun New" pitchFamily="34" charset="0"/>
-                <a:ea typeface="TH Sarabun New" pitchFamily="34" charset="-122"/>
-                <a:cs typeface="TH Sarabun New" pitchFamily="34" charset="-120"/>
-              </a:rPr>
-              <a:t>10 นาที</a:t>
-            </a:r>
-            <a:endParaRPr lang="en-US" sz="1700" dirty="0"/>
-          </a:p>
-        </p:txBody>
-      </p:sp>
-      <p:sp>
-        <p:nvSpPr>
-          <p:cNvPr id="7" name="Shape 5"/>
-          <p:cNvSpPr/>
-          <p:nvPr/>
-        </p:nvSpPr>
-        <p:spPr>
-          <a:xfrm>
-            <a:off x="594360" y="1024128"/>
-            <a:ext cx="5760720" cy="3794760"/>
-          </a:xfrm>
-          <a:prstGeom prst="roundRect">
-            <a:avLst>
-              <a:gd name="adj" fmla="val 2169"/>
-            </a:avLst>
-          </a:prstGeom>
-          <a:solidFill>
-            <a:srgbClr val="FFFFFF"/>
-          </a:solidFill>
-          <a:ln w="9525">
-            <a:solidFill>
-              <a:srgbClr val="FFFFFF"/>
-            </a:solidFill>
-            <a:prstDash val="solid"/>
-          </a:ln>
-          <a:effectLst>
-            <a:outerShdw blurRad="101600" dist="12700" dir="5400000" algn="bl" rotWithShape="0">
-              <a:srgbClr val="222831">
-                <a:alpha val="10000"/>
-              </a:srgbClr>
-            </a:outerShdw>
-          </a:effectLst>
-        </p:spPr>
-        <p:txBody>
-          <a:bodyPr/>
-          <a:lstStyle/>
-          <a:p>
-            <a:endParaRPr lang="en-TH"/>
-          </a:p>
-        </p:txBody>
-      </p:sp>
-      <p:sp>
-        <p:nvSpPr>
-          <p:cNvPr id="8" name="Text 6"/>
-          <p:cNvSpPr/>
-          <p:nvPr/>
-        </p:nvSpPr>
-        <p:spPr>
-          <a:xfrm>
-            <a:off x="850392" y="1188720"/>
-            <a:ext cx="5248656" cy="310896"/>
-          </a:xfrm>
-          <a:prstGeom prst="rect">
-            <a:avLst/>
-          </a:prstGeom>
-          <a:noFill/>
-          <a:ln/>
-        </p:spPr>
-        <p:txBody>
-          <a:bodyPr wrap="square" lIns="0" tIns="0" rIns="0" bIns="0" rtlCol="0" anchor="ctr"/>
-          <a:lstStyle/>
-          <a:p>
-            <a:pPr marL="0" indent="0">
-              <a:buNone/>
-            </a:pPr>
-            <a:r>
-              <a:rPr lang="en-US" sz="1900" b="1" dirty="0">
-                <a:solidFill>
-                  <a:srgbClr val="222831"/>
-                </a:solidFill>
-                <a:latin typeface="TH Sarabun New" pitchFamily="34" charset="0"/>
-                <a:ea typeface="TH Sarabun New" pitchFamily="34" charset="-122"/>
-                <a:cs typeface="TH Sarabun New" pitchFamily="34" charset="-120"/>
-              </a:rPr>
-              <a:t>สิ่งที่ต้องทำ</a:t>
-            </a:r>
-            <a:endParaRPr lang="en-US" sz="1900" dirty="0"/>
-          </a:p>
-        </p:txBody>
-      </p:sp>
-      <p:sp>
-        <p:nvSpPr>
-          <p:cNvPr id="9" name="Shape 7"/>
-          <p:cNvSpPr/>
-          <p:nvPr/>
-        </p:nvSpPr>
-        <p:spPr>
-          <a:xfrm>
-            <a:off x="868680" y="1636776"/>
-            <a:ext cx="329184" cy="329184"/>
-          </a:xfrm>
-          <a:prstGeom prst="ellipse">
-            <a:avLst/>
-          </a:prstGeom>
-          <a:solidFill>
-            <a:srgbClr val="00ADB5"/>
-          </a:solidFill>
-          <a:ln w="12700">
-            <a:solidFill>
-              <a:srgbClr val="00ADB5"/>
-            </a:solidFill>
-            <a:prstDash val="solid"/>
-          </a:ln>
-        </p:spPr>
-        <p:txBody>
-          <a:bodyPr/>
-          <a:lstStyle/>
-          <a:p>
-            <a:endParaRPr lang="en-TH"/>
-          </a:p>
-        </p:txBody>
-      </p:sp>
-      <p:sp>
-        <p:nvSpPr>
-          <p:cNvPr id="10" name="Text 8"/>
-          <p:cNvSpPr/>
-          <p:nvPr/>
-        </p:nvSpPr>
-        <p:spPr>
-          <a:xfrm>
-            <a:off x="868680" y="1636776"/>
-            <a:ext cx="329184" cy="329184"/>
-          </a:xfrm>
-          <a:prstGeom prst="rect">
-            <a:avLst/>
-          </a:prstGeom>
-          <a:noFill/>
-          <a:ln/>
-        </p:spPr>
-        <p:txBody>
-          <a:bodyPr wrap="square" lIns="0" tIns="0" rIns="0" bIns="0" rtlCol="0" anchor="ctr"/>
-          <a:lstStyle/>
-          <a:p>
-            <a:pPr marL="0" indent="0" algn="ctr">
-              <a:buNone/>
-            </a:pPr>
-            <a:r>
-              <a:rPr lang="en-US" sz="1500" b="1" dirty="0">
-                <a:solidFill>
-                  <a:srgbClr val="FFFFFF"/>
-                </a:solidFill>
-                <a:latin typeface="TH Sarabun New" pitchFamily="34" charset="0"/>
-                <a:ea typeface="TH Sarabun New" pitchFamily="34" charset="-122"/>
-                <a:cs typeface="TH Sarabun New" pitchFamily="34" charset="-120"/>
-              </a:rPr>
-              <a:t>1</a:t>
-            </a:r>
-            <a:endParaRPr lang="en-US" sz="1500" dirty="0"/>
-          </a:p>
-        </p:txBody>
-      </p:sp>
-      <p:sp>
-        <p:nvSpPr>
-          <p:cNvPr id="11" name="Text 9"/>
-          <p:cNvSpPr/>
-          <p:nvPr/>
-        </p:nvSpPr>
-        <p:spPr>
-          <a:xfrm>
-            <a:off x="1307592" y="1572768"/>
-            <a:ext cx="4754880" cy="457200"/>
-          </a:xfrm>
-          <a:prstGeom prst="rect">
-            <a:avLst/>
-          </a:prstGeom>
-          <a:noFill/>
-          <a:ln/>
-        </p:spPr>
-        <p:txBody>
-          <a:bodyPr wrap="square" lIns="0" tIns="0" rIns="0" bIns="0" rtlCol="0" anchor="ctr"/>
-          <a:lstStyle/>
-          <a:p>
-            <a:pPr marL="0" indent="0">
-              <a:buNone/>
-            </a:pPr>
-            <a:r>
-              <a:rPr lang="en-US" sz="1600" dirty="0">
-                <a:solidFill>
-                  <a:srgbClr val="393E46"/>
-                </a:solidFill>
-                <a:latin typeface="TH Sarabun New" pitchFamily="34" charset="0"/>
-                <a:ea typeface="TH Sarabun New" pitchFamily="34" charset="-122"/>
-                <a:cs typeface="TH Sarabun New" pitchFamily="34" charset="-120"/>
-              </a:rPr>
-              <a:t>ตรวจว่ามี Node.js, Git และ Antigravity IDE แล้ว</a:t>
-            </a:r>
-            <a:endParaRPr lang="en-US" sz="1600" dirty="0"/>
-          </a:p>
-        </p:txBody>
-      </p:sp>
-      <p:sp>
-        <p:nvSpPr>
-          <p:cNvPr id="12" name="Shape 10"/>
-          <p:cNvSpPr/>
-          <p:nvPr/>
-        </p:nvSpPr>
-        <p:spPr>
-          <a:xfrm>
-            <a:off x="868680" y="2221992"/>
-            <a:ext cx="329184" cy="329184"/>
-          </a:xfrm>
-          <a:prstGeom prst="ellipse">
-            <a:avLst/>
-          </a:prstGeom>
-          <a:solidFill>
-            <a:srgbClr val="00ADB5"/>
-          </a:solidFill>
-          <a:ln w="12700">
-            <a:solidFill>
-              <a:srgbClr val="00ADB5"/>
-            </a:solidFill>
-            <a:prstDash val="solid"/>
-          </a:ln>
-        </p:spPr>
-        <p:txBody>
-          <a:bodyPr/>
-          <a:lstStyle/>
-          <a:p>
-            <a:endParaRPr lang="en-TH"/>
-          </a:p>
-        </p:txBody>
-      </p:sp>
-      <p:sp>
-        <p:nvSpPr>
-          <p:cNvPr id="13" name="Text 11"/>
-          <p:cNvSpPr/>
-          <p:nvPr/>
-        </p:nvSpPr>
-        <p:spPr>
-          <a:xfrm>
-            <a:off x="868680" y="2221992"/>
-            <a:ext cx="329184" cy="329184"/>
-          </a:xfrm>
-          <a:prstGeom prst="rect">
-            <a:avLst/>
-          </a:prstGeom>
-          <a:noFill/>
-          <a:ln/>
-        </p:spPr>
-        <p:txBody>
-          <a:bodyPr wrap="square" lIns="0" tIns="0" rIns="0" bIns="0" rtlCol="0" anchor="ctr"/>
-          <a:lstStyle/>
-          <a:p>
-            <a:pPr marL="0" indent="0" algn="ctr">
-              <a:buNone/>
-            </a:pPr>
-            <a:r>
-              <a:rPr lang="en-US" sz="1500" b="1" dirty="0">
-                <a:solidFill>
-                  <a:srgbClr val="FFFFFF"/>
-                </a:solidFill>
-                <a:latin typeface="TH Sarabun New" pitchFamily="34" charset="0"/>
-                <a:ea typeface="TH Sarabun New" pitchFamily="34" charset="-122"/>
-                <a:cs typeface="TH Sarabun New" pitchFamily="34" charset="-120"/>
-              </a:rPr>
-              <a:t>2</a:t>
-            </a:r>
-            <a:endParaRPr lang="en-US" sz="1500" dirty="0"/>
-          </a:p>
-        </p:txBody>
-      </p:sp>
-      <p:sp>
-        <p:nvSpPr>
-          <p:cNvPr id="14" name="Text 12"/>
-          <p:cNvSpPr/>
-          <p:nvPr/>
-        </p:nvSpPr>
-        <p:spPr>
-          <a:xfrm>
-            <a:off x="1307592" y="2157984"/>
-            <a:ext cx="4754880" cy="457200"/>
-          </a:xfrm>
-          <a:prstGeom prst="rect">
-            <a:avLst/>
-          </a:prstGeom>
-          <a:noFill/>
-          <a:ln/>
-        </p:spPr>
-        <p:txBody>
-          <a:bodyPr wrap="square" lIns="0" tIns="0" rIns="0" bIns="0" rtlCol="0" anchor="ctr"/>
-          <a:lstStyle/>
-          <a:p>
-            <a:pPr marL="0" indent="0">
-              <a:buNone/>
-            </a:pPr>
-            <a:r>
-              <a:rPr lang="en-US" sz="1600" dirty="0">
-                <a:solidFill>
-                  <a:srgbClr val="393E46"/>
-                </a:solidFill>
-                <a:latin typeface="TH Sarabun New" pitchFamily="34" charset="0"/>
-                <a:ea typeface="TH Sarabun New" pitchFamily="34" charset="-122"/>
-                <a:cs typeface="TH Sarabun New" pitchFamily="34" charset="-120"/>
-              </a:rPr>
-              <a:t>สร้างโฟลเดอร์ fundinghub แล้วเปิดใน Antigravity</a:t>
-            </a:r>
-            <a:endParaRPr lang="en-US" sz="1600" dirty="0"/>
-          </a:p>
-        </p:txBody>
-      </p:sp>
-      <p:sp>
-        <p:nvSpPr>
-          <p:cNvPr id="15" name="Shape 13"/>
-          <p:cNvSpPr/>
-          <p:nvPr/>
-        </p:nvSpPr>
-        <p:spPr>
-          <a:xfrm>
-            <a:off x="868680" y="2807208"/>
-            <a:ext cx="329184" cy="329184"/>
-          </a:xfrm>
-          <a:prstGeom prst="ellipse">
-            <a:avLst/>
-          </a:prstGeom>
-          <a:solidFill>
-            <a:srgbClr val="00ADB5"/>
-          </a:solidFill>
-          <a:ln w="12700">
-            <a:solidFill>
-              <a:srgbClr val="00ADB5"/>
-            </a:solidFill>
-            <a:prstDash val="solid"/>
-          </a:ln>
-        </p:spPr>
-        <p:txBody>
-          <a:bodyPr/>
-          <a:lstStyle/>
-          <a:p>
-            <a:endParaRPr lang="en-TH"/>
-          </a:p>
-        </p:txBody>
-      </p:sp>
-      <p:sp>
-        <p:nvSpPr>
-          <p:cNvPr id="16" name="Text 14"/>
-          <p:cNvSpPr/>
-          <p:nvPr/>
-        </p:nvSpPr>
-        <p:spPr>
-          <a:xfrm>
-            <a:off x="868680" y="2807208"/>
-            <a:ext cx="329184" cy="329184"/>
-          </a:xfrm>
-          <a:prstGeom prst="rect">
-            <a:avLst/>
-          </a:prstGeom>
-          <a:noFill/>
-          <a:ln/>
-        </p:spPr>
-        <p:txBody>
-          <a:bodyPr wrap="square" lIns="0" tIns="0" rIns="0" bIns="0" rtlCol="0" anchor="ctr"/>
-          <a:lstStyle/>
-          <a:p>
-            <a:pPr marL="0" indent="0" algn="ctr">
-              <a:buNone/>
-            </a:pPr>
-            <a:r>
-              <a:rPr lang="en-US" sz="1500" b="1" dirty="0">
-                <a:solidFill>
-                  <a:srgbClr val="FFFFFF"/>
-                </a:solidFill>
-                <a:latin typeface="TH Sarabun New" pitchFamily="34" charset="0"/>
-                <a:ea typeface="TH Sarabun New" pitchFamily="34" charset="-122"/>
-                <a:cs typeface="TH Sarabun New" pitchFamily="34" charset="-120"/>
-              </a:rPr>
-              <a:t>3</a:t>
-            </a:r>
-            <a:endParaRPr lang="en-US" sz="1500" dirty="0"/>
-          </a:p>
-        </p:txBody>
-      </p:sp>
-      <p:sp>
-        <p:nvSpPr>
-          <p:cNvPr id="17" name="Text 15"/>
-          <p:cNvSpPr/>
-          <p:nvPr/>
-        </p:nvSpPr>
-        <p:spPr>
-          <a:xfrm>
-            <a:off x="1307592" y="2743200"/>
-            <a:ext cx="4754880" cy="457200"/>
-          </a:xfrm>
-          <a:prstGeom prst="rect">
-            <a:avLst/>
-          </a:prstGeom>
-          <a:noFill/>
-          <a:ln/>
-        </p:spPr>
-        <p:txBody>
-          <a:bodyPr wrap="square" lIns="0" tIns="0" rIns="0" bIns="0" rtlCol="0" anchor="ctr"/>
-          <a:lstStyle/>
-          <a:p>
-            <a:pPr marL="0" indent="0">
-              <a:buNone/>
-            </a:pPr>
-            <a:r>
-              <a:rPr lang="en-US" sz="1600" dirty="0">
-                <a:solidFill>
-                  <a:srgbClr val="393E46"/>
-                </a:solidFill>
-                <a:latin typeface="TH Sarabun New" pitchFamily="34" charset="0"/>
-                <a:ea typeface="TH Sarabun New" pitchFamily="34" charset="-122"/>
-                <a:cs typeface="TH Sarabun New" pitchFamily="34" charset="-120"/>
-              </a:rPr>
-              <a:t>สร้างไฟล์เปล่าชื่อ SPEC_FundingHub.md ที่รากโปรเจกต์</a:t>
-            </a:r>
-            <a:endParaRPr lang="en-US" sz="1600" dirty="0"/>
-          </a:p>
-        </p:txBody>
-      </p:sp>
-      <p:sp>
-        <p:nvSpPr>
-          <p:cNvPr id="18" name="Shape 16"/>
-          <p:cNvSpPr/>
-          <p:nvPr/>
-        </p:nvSpPr>
-        <p:spPr>
-          <a:xfrm>
-            <a:off x="868680" y="3392424"/>
-            <a:ext cx="329184" cy="329184"/>
-          </a:xfrm>
-          <a:prstGeom prst="ellipse">
-            <a:avLst/>
-          </a:prstGeom>
-          <a:solidFill>
-            <a:srgbClr val="00ADB5"/>
-          </a:solidFill>
-          <a:ln w="12700">
-            <a:solidFill>
-              <a:srgbClr val="00ADB5"/>
-            </a:solidFill>
-            <a:prstDash val="solid"/>
-          </a:ln>
-        </p:spPr>
-        <p:txBody>
-          <a:bodyPr/>
-          <a:lstStyle/>
-          <a:p>
-            <a:endParaRPr lang="en-TH"/>
-          </a:p>
-        </p:txBody>
-      </p:sp>
-      <p:sp>
-        <p:nvSpPr>
-          <p:cNvPr id="19" name="Text 17"/>
-          <p:cNvSpPr/>
-          <p:nvPr/>
-        </p:nvSpPr>
-        <p:spPr>
-          <a:xfrm>
-            <a:off x="868680" y="3392424"/>
-            <a:ext cx="329184" cy="329184"/>
-          </a:xfrm>
-          <a:prstGeom prst="rect">
-            <a:avLst/>
-          </a:prstGeom>
-          <a:noFill/>
-          <a:ln/>
-        </p:spPr>
-        <p:txBody>
-          <a:bodyPr wrap="square" lIns="0" tIns="0" rIns="0" bIns="0" rtlCol="0" anchor="ctr"/>
-          <a:lstStyle/>
-          <a:p>
-            <a:pPr marL="0" indent="0" algn="ctr">
-              <a:buNone/>
-            </a:pPr>
-            <a:r>
-              <a:rPr lang="en-US" sz="1500" b="1" dirty="0">
-                <a:solidFill>
-                  <a:srgbClr val="FFFFFF"/>
-                </a:solidFill>
-                <a:latin typeface="TH Sarabun New" pitchFamily="34" charset="0"/>
-                <a:ea typeface="TH Sarabun New" pitchFamily="34" charset="-122"/>
-                <a:cs typeface="TH Sarabun New" pitchFamily="34" charset="-120"/>
-              </a:rPr>
-              <a:t>4</a:t>
-            </a:r>
-            <a:endParaRPr lang="en-US" sz="1500" dirty="0"/>
-          </a:p>
-        </p:txBody>
-      </p:sp>
-      <p:sp>
-        <p:nvSpPr>
-          <p:cNvPr id="20" name="Text 18"/>
-          <p:cNvSpPr/>
-          <p:nvPr/>
-        </p:nvSpPr>
-        <p:spPr>
-          <a:xfrm>
-            <a:off x="1307592" y="3328416"/>
-            <a:ext cx="4754880" cy="457200"/>
-          </a:xfrm>
-          <a:prstGeom prst="rect">
-            <a:avLst/>
-          </a:prstGeom>
-          <a:noFill/>
-          <a:ln/>
-        </p:spPr>
-        <p:txBody>
-          <a:bodyPr wrap="square" lIns="0" tIns="0" rIns="0" bIns="0" rtlCol="0" anchor="ctr"/>
-          <a:lstStyle/>
-          <a:p>
-            <a:pPr marL="0" indent="0">
-              <a:buNone/>
-            </a:pPr>
-            <a:r>
-              <a:rPr lang="en-US" sz="1600" dirty="0">
-                <a:solidFill>
-                  <a:srgbClr val="393E46"/>
-                </a:solidFill>
-                <a:latin typeface="TH Sarabun New" pitchFamily="34" charset="0"/>
-                <a:ea typeface="TH Sarabun New" pitchFamily="34" charset="-122"/>
-                <a:cs typeface="TH Sarabun New" pitchFamily="34" charset="-120"/>
-              </a:rPr>
-              <a:t>เปิดไฟล์ SPEC_BLOCKS.md ที่แจกให้ ไว้อีกหน้าต่างหนึ่ง</a:t>
-            </a:r>
-            <a:endParaRPr lang="en-US" sz="1600" dirty="0"/>
-          </a:p>
-        </p:txBody>
-      </p:sp>
-      <p:sp>
-        <p:nvSpPr>
-          <p:cNvPr id="21" name="Shape 19"/>
-          <p:cNvSpPr/>
-          <p:nvPr/>
-        </p:nvSpPr>
-        <p:spPr>
-          <a:xfrm>
-            <a:off x="868680" y="3977640"/>
-            <a:ext cx="329184" cy="329184"/>
-          </a:xfrm>
-          <a:prstGeom prst="ellipse">
-            <a:avLst/>
-          </a:prstGeom>
-          <a:solidFill>
-            <a:srgbClr val="00ADB5"/>
-          </a:solidFill>
-          <a:ln w="12700">
-            <a:solidFill>
-              <a:srgbClr val="00ADB5"/>
-            </a:solidFill>
-            <a:prstDash val="solid"/>
-          </a:ln>
-        </p:spPr>
-        <p:txBody>
-          <a:bodyPr/>
-          <a:lstStyle/>
-          <a:p>
-            <a:endParaRPr lang="en-TH"/>
-          </a:p>
-        </p:txBody>
-      </p:sp>
-      <p:sp>
-        <p:nvSpPr>
-          <p:cNvPr id="22" name="Text 20"/>
-          <p:cNvSpPr/>
-          <p:nvPr/>
-        </p:nvSpPr>
-        <p:spPr>
-          <a:xfrm>
-            <a:off x="868680" y="3977640"/>
-            <a:ext cx="329184" cy="329184"/>
-          </a:xfrm>
-          <a:prstGeom prst="rect">
-            <a:avLst/>
-          </a:prstGeom>
-          <a:noFill/>
-          <a:ln/>
-        </p:spPr>
-        <p:txBody>
-          <a:bodyPr wrap="square" lIns="0" tIns="0" rIns="0" bIns="0" rtlCol="0" anchor="ctr"/>
-          <a:lstStyle/>
-          <a:p>
-            <a:pPr marL="0" indent="0" algn="ctr">
-              <a:buNone/>
-            </a:pPr>
-            <a:r>
-              <a:rPr lang="en-US" sz="1500" b="1" dirty="0">
-                <a:solidFill>
-                  <a:srgbClr val="FFFFFF"/>
-                </a:solidFill>
-                <a:latin typeface="TH Sarabun New" pitchFamily="34" charset="0"/>
-                <a:ea typeface="TH Sarabun New" pitchFamily="34" charset="-122"/>
-                <a:cs typeface="TH Sarabun New" pitchFamily="34" charset="-120"/>
-              </a:rPr>
-              <a:t>5</a:t>
-            </a:r>
-            <a:endParaRPr lang="en-US" sz="1500" dirty="0"/>
-          </a:p>
-        </p:txBody>
-      </p:sp>
-      <p:sp>
-        <p:nvSpPr>
-          <p:cNvPr id="23" name="Text 21"/>
-          <p:cNvSpPr/>
-          <p:nvPr/>
-        </p:nvSpPr>
-        <p:spPr>
-          <a:xfrm>
-            <a:off x="1307592" y="3913632"/>
-            <a:ext cx="4754880" cy="457200"/>
-          </a:xfrm>
-          <a:prstGeom prst="rect">
-            <a:avLst/>
-          </a:prstGeom>
-          <a:noFill/>
-          <a:ln/>
-        </p:spPr>
-        <p:txBody>
-          <a:bodyPr wrap="square" lIns="0" tIns="0" rIns="0" bIns="0" rtlCol="0" anchor="ctr"/>
-          <a:lstStyle/>
-          <a:p>
-            <a:pPr marL="0" indent="0">
-              <a:buNone/>
-            </a:pPr>
-            <a:r>
-              <a:rPr lang="en-US" sz="1600" dirty="0">
-                <a:solidFill>
-                  <a:srgbClr val="393E46"/>
-                </a:solidFill>
-                <a:latin typeface="TH Sarabun New" pitchFamily="34" charset="0"/>
-                <a:ea typeface="TH Sarabun New" pitchFamily="34" charset="-122"/>
-                <a:cs typeface="TH Sarabun New" pitchFamily="34" charset="-120"/>
-              </a:rPr>
-              <a:t>หาให้เจอ 4 ส่วน : Editor / Agent / Artifacts / Browser</a:t>
-            </a:r>
-            <a:endParaRPr lang="en-US" sz="1600" dirty="0"/>
-          </a:p>
-        </p:txBody>
-      </p:sp>
-      <p:sp>
-        <p:nvSpPr>
-          <p:cNvPr id="24" name="Shape 22"/>
-          <p:cNvSpPr/>
-          <p:nvPr/>
-        </p:nvSpPr>
-        <p:spPr>
-          <a:xfrm>
-            <a:off x="6583680" y="1024128"/>
-            <a:ext cx="4983480" cy="1600200"/>
-          </a:xfrm>
-          <a:prstGeom prst="roundRect">
-            <a:avLst>
-              <a:gd name="adj" fmla="val 4000"/>
-            </a:avLst>
-          </a:prstGeom>
-          <a:solidFill>
-            <a:srgbClr val="222831"/>
-          </a:solidFill>
-          <a:ln w="12700">
-            <a:solidFill>
-              <a:srgbClr val="222831"/>
-            </a:solidFill>
-            <a:prstDash val="solid"/>
-          </a:ln>
-        </p:spPr>
-        <p:txBody>
-          <a:bodyPr/>
-          <a:lstStyle/>
-          <a:p>
-            <a:endParaRPr lang="en-TH"/>
-          </a:p>
-        </p:txBody>
-      </p:sp>
-      <p:sp>
-        <p:nvSpPr>
-          <p:cNvPr id="25" name="Text 23"/>
-          <p:cNvSpPr/>
-          <p:nvPr/>
-        </p:nvSpPr>
-        <p:spPr>
-          <a:xfrm>
-            <a:off x="6729984" y="1115568"/>
-            <a:ext cx="4690872" cy="1417320"/>
-          </a:xfrm>
-          <a:prstGeom prst="rect">
-            <a:avLst/>
-          </a:prstGeom>
-          <a:noFill/>
-          <a:ln/>
-        </p:spPr>
-        <p:txBody>
-          <a:bodyPr wrap="square" lIns="0" tIns="0" rIns="0" bIns="0" rtlCol="0" anchor="t"/>
-          <a:lstStyle/>
-          <a:p>
-            <a:pPr marL="0" indent="0">
-              <a:lnSpc>
-                <a:spcPts val="1700"/>
-              </a:lnSpc>
-              <a:buNone/>
-            </a:pPr>
-            <a:r>
-              <a:rPr lang="en-US" sz="1150" dirty="0">
-                <a:solidFill>
-                  <a:srgbClr val="D6F5F7"/>
-                </a:solidFill>
-                <a:latin typeface="Courier New" pitchFamily="34" charset="0"/>
-                <a:ea typeface="Courier New" pitchFamily="34" charset="-122"/>
-                <a:cs typeface="Courier New" pitchFamily="34" charset="-120"/>
-              </a:rPr>
-              <a:t>node -v</a:t>
-            </a:r>
-            <a:endParaRPr lang="en-US" sz="1150" dirty="0"/>
-          </a:p>
-          <a:p>
-            <a:pPr marL="0" indent="0">
-              <a:lnSpc>
-                <a:spcPts val="1700"/>
-              </a:lnSpc>
-              <a:buNone/>
-            </a:pPr>
-            <a:r>
-              <a:rPr lang="en-US" sz="1150" dirty="0">
-                <a:solidFill>
-                  <a:srgbClr val="D6F5F7"/>
-                </a:solidFill>
-                <a:latin typeface="Courier New" pitchFamily="34" charset="0"/>
-                <a:ea typeface="Courier New" pitchFamily="34" charset="-122"/>
-                <a:cs typeface="Courier New" pitchFamily="34" charset="-120"/>
-              </a:rPr>
-              <a:t>npm -v</a:t>
-            </a:r>
-            <a:endParaRPr lang="en-US" sz="1150" dirty="0"/>
-          </a:p>
-          <a:p>
-            <a:pPr marL="0" indent="0">
-              <a:lnSpc>
-                <a:spcPts val="1700"/>
-              </a:lnSpc>
-              <a:buNone/>
-            </a:pPr>
-            <a:r>
-              <a:rPr lang="en-US" sz="1150" dirty="0">
-                <a:solidFill>
-                  <a:srgbClr val="D6F5F7"/>
-                </a:solidFill>
-                <a:latin typeface="Courier New" pitchFamily="34" charset="0"/>
-                <a:ea typeface="Courier New" pitchFamily="34" charset="-122"/>
-                <a:cs typeface="Courier New" pitchFamily="34" charset="-120"/>
-              </a:rPr>
-              <a:t>git --version</a:t>
-            </a:r>
-            <a:endParaRPr lang="en-US" sz="1150" dirty="0"/>
-          </a:p>
-        </p:txBody>
-      </p:sp>
-      <p:sp>
-        <p:nvSpPr>
-          <p:cNvPr id="26" name="Shape 24"/>
-          <p:cNvSpPr/>
-          <p:nvPr/>
-        </p:nvSpPr>
-        <p:spPr>
-          <a:xfrm>
-            <a:off x="6583680" y="2788920"/>
-            <a:ext cx="4983480" cy="2029968"/>
-          </a:xfrm>
-          <a:prstGeom prst="roundRect">
-            <a:avLst>
-              <a:gd name="adj" fmla="val 4054"/>
-            </a:avLst>
-          </a:prstGeom>
-          <a:solidFill>
-            <a:srgbClr val="FFFFFF"/>
-          </a:solidFill>
-          <a:ln w="9525">
-            <a:solidFill>
-              <a:srgbClr val="FFFFFF"/>
-            </a:solidFill>
-            <a:prstDash val="solid"/>
-          </a:ln>
-          <a:effectLst>
-            <a:outerShdw blurRad="101600" dist="12700" dir="5400000" algn="bl" rotWithShape="0">
-              <a:srgbClr val="222831">
-                <a:alpha val="10000"/>
-              </a:srgbClr>
-            </a:outerShdw>
-          </a:effectLst>
-        </p:spPr>
-        <p:txBody>
-          <a:bodyPr/>
-          <a:lstStyle/>
-          <a:p>
-            <a:endParaRPr lang="en-TH"/>
-          </a:p>
-        </p:txBody>
-      </p:sp>
-      <p:sp>
-        <p:nvSpPr>
-          <p:cNvPr id="27" name="Text 25"/>
-          <p:cNvSpPr/>
-          <p:nvPr/>
-        </p:nvSpPr>
-        <p:spPr>
-          <a:xfrm>
-            <a:off x="6812280" y="2926080"/>
-            <a:ext cx="4526280" cy="310896"/>
-          </a:xfrm>
-          <a:prstGeom prst="rect">
-            <a:avLst/>
-          </a:prstGeom>
-          <a:noFill/>
-          <a:ln/>
-        </p:spPr>
-        <p:txBody>
-          <a:bodyPr wrap="square" lIns="0" tIns="0" rIns="0" bIns="0" rtlCol="0" anchor="ctr"/>
-          <a:lstStyle/>
-          <a:p>
-            <a:pPr marL="0" indent="0">
-              <a:buNone/>
-            </a:pPr>
-            <a:r>
-              <a:rPr lang="en-US" sz="1800" b="1" dirty="0">
-                <a:solidFill>
-                  <a:srgbClr val="222831"/>
-                </a:solidFill>
-                <a:latin typeface="TH Sarabun New" pitchFamily="34" charset="0"/>
-                <a:ea typeface="TH Sarabun New" pitchFamily="34" charset="-122"/>
-                <a:cs typeface="TH Sarabun New" pitchFamily="34" charset="-120"/>
-              </a:rPr>
-              <a:t>เกณฑ์ผ่าน</a:t>
-            </a:r>
-            <a:endParaRPr lang="en-US" sz="1800" dirty="0"/>
-          </a:p>
-        </p:txBody>
-      </p:sp>
-      <p:sp>
-        <p:nvSpPr>
-          <p:cNvPr id="28" name="Text 26"/>
-          <p:cNvSpPr/>
-          <p:nvPr/>
-        </p:nvSpPr>
-        <p:spPr>
-          <a:xfrm>
-            <a:off x="6812280" y="3310128"/>
-            <a:ext cx="4480560" cy="1371600"/>
-          </a:xfrm>
-          <a:prstGeom prst="rect">
-            <a:avLst/>
-          </a:prstGeom>
-          <a:noFill/>
-          <a:ln/>
-        </p:spPr>
-        <p:txBody>
-          <a:bodyPr wrap="square" lIns="0" tIns="0" rIns="0" bIns="0" rtlCol="0" anchor="t"/>
-          <a:lstStyle/>
-          <a:p>
-            <a:pPr marL="342900" indent="-342900">
-              <a:spcAft>
-                <a:spcPts val="800"/>
-              </a:spcAft>
-              <a:buSzPct val="100000"/>
-              <a:buChar char="•"/>
-            </a:pPr>
-            <a:r>
-              <a:rPr lang="en-US" sz="1550" dirty="0">
-                <a:solidFill>
-                  <a:srgbClr val="393E46"/>
-                </a:solidFill>
-                <a:latin typeface="TH Sarabun New" pitchFamily="34" charset="0"/>
-                <a:ea typeface="TH Sarabun New" pitchFamily="34" charset="-122"/>
-                <a:cs typeface="TH Sarabun New" pitchFamily="34" charset="-120"/>
-              </a:rPr>
-              <a:t>ทุกคำสั่งขึ้นเลขเวอร์ชัน ไม่ขึ้น command not found</a:t>
-            </a:r>
-            <a:endParaRPr lang="en-US" sz="1550" dirty="0"/>
-          </a:p>
-          <a:p>
-            <a:pPr marL="342900" indent="-342900">
-              <a:spcAft>
-                <a:spcPts val="800"/>
-              </a:spcAft>
-              <a:buSzPct val="100000"/>
-              <a:buChar char="•"/>
-            </a:pPr>
-            <a:r>
-              <a:rPr lang="en-US" sz="1550" dirty="0">
-                <a:solidFill>
-                  <a:srgbClr val="393E46"/>
-                </a:solidFill>
-                <a:latin typeface="TH Sarabun New" pitchFamily="34" charset="0"/>
-                <a:ea typeface="TH Sarabun New" pitchFamily="34" charset="-122"/>
-                <a:cs typeface="TH Sarabun New" pitchFamily="34" charset="-120"/>
-              </a:rPr>
-              <a:t>เปิดโฟลเดอร์ fundinghub ใน Antigravity ได้</a:t>
-            </a:r>
-            <a:endParaRPr lang="en-US" sz="1550" dirty="0"/>
-          </a:p>
-          <a:p>
-            <a:pPr marL="342900" indent="-342900">
-              <a:spcAft>
-                <a:spcPts val="800"/>
-              </a:spcAft>
-              <a:buSzPct val="100000"/>
-              <a:buChar char="•"/>
-            </a:pPr>
-            <a:r>
-              <a:rPr lang="en-US" sz="1550" dirty="0">
-                <a:solidFill>
-                  <a:srgbClr val="393E46"/>
-                </a:solidFill>
-                <a:latin typeface="TH Sarabun New" pitchFamily="34" charset="0"/>
-                <a:ea typeface="TH Sarabun New" pitchFamily="34" charset="-122"/>
-                <a:cs typeface="TH Sarabun New" pitchFamily="34" charset="-120"/>
-              </a:rPr>
-              <a:t>มีไฟล์เปล่า SPEC_FundingHub.md รออยู่</a:t>
-            </a:r>
-            <a:endParaRPr lang="en-US" sz="1550" dirty="0"/>
-          </a:p>
-        </p:txBody>
-      </p:sp>
-      <p:sp>
-        <p:nvSpPr>
-          <p:cNvPr id="29" name="Text 27"/>
-          <p:cNvSpPr/>
-          <p:nvPr/>
-        </p:nvSpPr>
-        <p:spPr>
-          <a:xfrm>
-            <a:off x="594360" y="6263640"/>
-            <a:ext cx="10972800" cy="292608"/>
-          </a:xfrm>
-          <a:prstGeom prst="rect">
-            <a:avLst/>
-          </a:prstGeom>
-          <a:noFill/>
-          <a:ln/>
-        </p:spPr>
-        <p:txBody>
-          <a:bodyPr wrap="square" lIns="0" tIns="0" rIns="0" bIns="0" rtlCol="0" anchor="ctr"/>
-          <a:lstStyle/>
-          <a:p>
-            <a:pPr marL="0" indent="0">
-              <a:buNone/>
-            </a:pPr>
-            <a:r>
-              <a:rPr lang="en-US" sz="1300" dirty="0">
-                <a:solidFill>
-                  <a:srgbClr val="8A94A6"/>
-                </a:solidFill>
-                <a:latin typeface="TH Sarabun New" pitchFamily="34" charset="0"/>
-                <a:ea typeface="TH Sarabun New" pitchFamily="34" charset="-122"/>
-                <a:cs typeface="TH Sarabun New" pitchFamily="34" charset="-120"/>
-              </a:rPr>
-              <a:t>เอกสารแล็บ : LAB A  ·  การติดตั้งควรทำมาล่วงหน้าก่อนวันอบรม เวลาในห้องมีเพียง 10 นาทีสำหรับตรวจความพร้อม</a:t>
-            </a:r>
-            <a:endParaRPr lang="en-US" sz="1300" dirty="0"/>
           </a:p>
         </p:txBody>
       </p:sp>

</xml_diff>